<commit_message>
Add UI screenshots; fix explain-on-empty-section, section-citation resolver, summarize guard; embed screenshots in README and slides; sharpen business payoff and change-detection framing
</commit_message>
<xml_diff>
--- a/Slides.pptx
+++ b/Slides.pptx
@@ -16,9 +16,10 @@
     <p:sldId id="264" r:id="rId10"/>
     <p:sldId id="265" r:id="rId11"/>
     <p:sldId id="266" r:id="rId12"/>
+    <p:sldId id="267" r:id="rId13"/>
   </p:sldIdLst>
   <p:notesMasterIdLst>
-    <p:notesMasterId r:id="rId13"/>
+    <p:notesMasterId r:id="rId14"/>
   </p:notesMasterIdLst>
   <p:sldSz cx="12192000" cy="6858000"/>
   <p:notesSz cx="6858000" cy="12192000"/>
@@ -933,7 +934,7 @@
           <a:p>
             <a:r>
               <a:rPr lang="en-US" dirty="0"/>
-              <a:t>The judgment slide. We stayed within the actual ask, a working POC rather than a production model. A POC's job is to prove feasibility, and the agent plus grounding already does that. Training needs labeled data we do not have yet, and a learned prediction is harder to ground than a cited quote, which is the whole trust mechanism. Once the workflow runs at scale and produces verified data, a trained model becomes a natural v2, and I am open to building it separately and discussing it in the interview.</a:t>
+              <a:t>Stated limits read as competence: keyword retrieval, small eval set, model-agnostic, and the deliberate decision not to train a model for a POC, with where training fits in a v2.</a:t>
             </a:r>
             <a:endParaRPr lang="en-US" dirty="0"/>
           </a:p>
@@ -1021,7 +1022,7 @@
           <a:p>
             <a:r>
               <a:rPr lang="en-US" dirty="0"/>
-              <a:t>Close on the recommendation: keep the expert, change their job from authoring rules to verifying source-cited drafts. Repo and email are on screen. Thank you.</a:t>
+              <a:t>The judgment slide. We stayed within the actual ask, a working POC rather than a production model. A POC's job is to prove feasibility, and the agent plus grounding already does that. Training needs labeled data we do not have yet, and a learned prediction is harder to ground than a cited quote, which is the whole trust mechanism. Once the workflow runs at scale and produces verified data, a trained model becomes a natural v2, and I am open to building it separately and discussing it in the interview.</a:t>
             </a:r>
             <a:endParaRPr lang="en-US" dirty="0"/>
           </a:p>
@@ -1045,6 +1046,94 @@
             <a:fld id="{F7021451-1387-4CA6-816F-3879F97B5CBC}" type="slidenum">
               <a:rPr lang="en-US"/>
               <a:t>11</a:t>
+            </a:fld>
+            <a:endParaRPr lang="en-US"/>
+          </a:p>
+        </p:txBody>
+      </p:sp>
+    </p:spTree>
+    <p:extLst>
+      <p:ext uri="{BB962C8B-B14F-4D97-AF65-F5344CB8AC3E}">
+        <p14:creationId xmlns:p14="http://schemas.microsoft.com/office/powerpoint/2010/main" val="1024086991"/>
+      </p:ext>
+    </p:extLst>
+  </p:cSld>
+  <p:clrMapOvr>
+    <a:masterClrMapping/>
+  </p:clrMapOvr>
+</p:notes>
+</file>
+
+<file path=ppt/notesSlides/notesSlide12.xml><?xml version="1.0" encoding="utf-8"?>
+<p:notes xmlns:a="http://schemas.openxmlformats.org/drawingml/2006/main" xmlns:r="http://schemas.openxmlformats.org/officeDocument/2006/relationships" xmlns:p="http://schemas.openxmlformats.org/presentationml/2006/main">
+  <p:cSld>
+    <p:spTree>
+      <p:nvGrpSpPr>
+        <p:cNvPr id="1" name=""/>
+        <p:cNvGrpSpPr/>
+        <p:nvPr/>
+      </p:nvGrpSpPr>
+      <p:grpSpPr>
+        <a:xfrm>
+          <a:off x="0" y="0"/>
+          <a:ext cx="0" cy="0"/>
+          <a:chOff x="0" y="0"/>
+          <a:chExt cx="0" cy="0"/>
+        </a:xfrm>
+      </p:grpSpPr>
+      <p:sp>
+        <p:nvSpPr>
+          <p:cNvPr id="2" name="Slide Image Placeholder 1"/>
+          <p:cNvSpPr>
+            <a:spLocks noGrp="1" noRot="1" noChangeAspect="1"/>
+          </p:cNvSpPr>
+          <p:nvPr>
+            <p:ph type="sldImg"/>
+          </p:nvPr>
+        </p:nvSpPr>
+        <p:spPr/>
+      </p:sp>
+      <p:sp>
+        <p:nvSpPr>
+          <p:cNvPr id="3" name="Notes Placeholder 2"/>
+          <p:cNvSpPr>
+            <a:spLocks noGrp="1"/>
+          </p:cNvSpPr>
+          <p:nvPr>
+            <p:ph type="body" idx="1"/>
+          </p:nvPr>
+        </p:nvSpPr>
+        <p:spPr/>
+        <p:txBody>
+          <a:bodyPr/>
+          <a:lstStyle/>
+          <a:p>
+            <a:r>
+              <a:rPr lang="en-US" dirty="0"/>
+              <a:t>Close on the recommendation: keep the expert, change their job from authoring rules to verifying source-cited drafts. The business payoff is a shorter path from a guideline change to a live claim edit, with an audit trail. Repo and email are on screen. Thank you.</a:t>
+            </a:r>
+            <a:endParaRPr lang="en-US" dirty="0"/>
+          </a:p>
+        </p:txBody>
+      </p:sp>
+      <p:sp>
+        <p:nvSpPr>
+          <p:cNvPr id="4" name="Slide Number Placeholder 3"/>
+          <p:cNvSpPr>
+            <a:spLocks noGrp="1"/>
+          </p:cNvSpPr>
+          <p:nvPr>
+            <p:ph type="sldNum" sz="quarter" idx="10"/>
+          </p:nvPr>
+        </p:nvSpPr>
+        <p:spPr/>
+        <p:txBody>
+          <a:bodyPr/>
+          <a:lstStyle/>
+          <a:p>
+            <a:fld id="{F7021451-1387-4CA6-816F-3879F97B5CBC}" type="slidenum">
+              <a:rPr lang="en-US"/>
+              <a:t>12</a:t>
             </a:fld>
             <a:endParaRPr lang="en-US"/>
           </a:p>
@@ -1461,7 +1550,7 @@
           <a:p>
             <a:r>
               <a:rPr lang="en-US" dirty="0"/>
-              <a:t>This is the differentiator. Generation and verification are separated: the model proposes rules, a deterministic check confirms each quote is real. Green grounds, red flags.</a:t>
+              <a:t>This is the differentiator. Generation and verification are separated: the model proposes rules, a deterministic check confirms each quote is real. Green grounds, red flags. This is a real screenshot of the app's extracted rules.</a:t>
             </a:r>
             <a:endParaRPr lang="en-US" dirty="0"/>
           </a:p>
@@ -1549,7 +1638,7 @@
           <a:p>
             <a:r>
               <a:rPr lang="en-US" dirty="0"/>
-              <a:t>Hand-off slide. Stop sharing slides, share the app. Run the three steps in order. If anything glitches, the static slides ahead still convey the results.</a:t>
+              <a:t>This proves the third capability, change detection. The diff is deterministic; the explanation is the one LLM touch. Section Q is a real retirement: Gender-Specific Procedures became Reserved for future use in 2025. In production this is the signal that a rule tied to Q should be reviewed.</a:t>
             </a:r>
             <a:endParaRPr lang="en-US" dirty="0"/>
           </a:p>
@@ -1637,7 +1726,7 @@
           <a:p>
             <a:r>
               <a:rPr lang="en-US" dirty="0"/>
-              <a:t>We hit 100% on good runs, but the model varies, so we report the range. The eval set is small on purpose. Reporting the spread, not the best number, is the point.</a:t>
+              <a:t>Hand-off slide. Stop sharing slides, share the app. Run the three steps in order. If anything glitches, the static slides ahead still convey the results.</a:t>
             </a:r>
             <a:endParaRPr lang="en-US" dirty="0"/>
           </a:p>
@@ -1725,7 +1814,7 @@
           <a:p>
             <a:r>
               <a:rPr lang="en-US" dirty="0"/>
-              <a:t>Stated limits read as competence: keyword retrieval, small eval set, model-agnostic, and the deliberate decision not to train a model for a POC, with where training fits in a v2.</a:t>
+              <a:t>We hit 100% on good runs, but the model varies, so we report the range. The screenshot is real output from the evaluation harness, showing the metrics plus the honest failure analysis: one missed provision and one flagged ungrounded rule.</a:t>
             </a:r>
             <a:endParaRPr lang="en-US" dirty="0"/>
           </a:p>
@@ -2537,7 +2626,7 @@
                 <a:ea typeface="Cambria" pitchFamily="34" charset="-122"/>
                 <a:cs typeface="Cambria" pitchFamily="34" charset="-120"/>
               </a:rPr>
-              <a:t>A deliberate choice: we did not train a model (yet)</a:t>
+              <a:t>Limitations and what is next</a:t>
             </a:r>
             <a:endParaRPr lang="en-US" sz="3000" dirty="0"/>
           </a:p>
@@ -2545,57 +2634,18 @@
       </p:sp>
       <p:sp>
         <p:nvSpPr>
-          <p:cNvPr id="3" name="Text 1"/>
-          <p:cNvSpPr/>
-          <p:nvPr/>
-        </p:nvSpPr>
-        <p:spPr>
-          <a:xfrm>
-            <a:off x="640080" y="1051560"/>
-            <a:ext cx="10881360" cy="365760"/>
-          </a:xfrm>
-          <a:prstGeom prst="rect">
-            <a:avLst/>
-          </a:prstGeom>
-          <a:noFill/>
-          <a:ln/>
-        </p:spPr>
-        <p:txBody>
-          <a:bodyPr wrap="square" lIns="0" tIns="0" rIns="0" bIns="0" rtlCol="0" anchor="ctr"/>
-          <a:lstStyle/>
-          <a:p>
-            <a:pPr indent="0" marL="0">
-              <a:buNone/>
-            </a:pPr>
-            <a:r>
-              <a:rPr lang="en-US" sz="1500" dirty="0">
-                <a:solidFill>
-                  <a:srgbClr val="64748B"/>
-                </a:solidFill>
-                <a:latin typeface="Calibri" pitchFamily="34" charset="0"/>
-                <a:ea typeface="Calibri" pitchFamily="34" charset="-122"/>
-                <a:cs typeface="Calibri" pitchFamily="34" charset="-120"/>
-              </a:rPr>
-              <a:t>Knowing when not to reach for the heavier tool</a:t>
-            </a:r>
-            <a:endParaRPr lang="en-US" sz="1500" dirty="0"/>
-          </a:p>
-        </p:txBody>
-      </p:sp>
-      <p:sp>
-        <p:nvSpPr>
-          <p:cNvPr id="4" name="Shape 2"/>
-          <p:cNvSpPr/>
-          <p:nvPr/>
-        </p:nvSpPr>
-        <p:spPr>
-          <a:xfrm>
-            <a:off x="640080" y="1737360"/>
-            <a:ext cx="5349240" cy="2743200"/>
+          <p:cNvPr id="3" name="Shape 1"/>
+          <p:cNvSpPr/>
+          <p:nvPr/>
+        </p:nvSpPr>
+        <p:spPr>
+          <a:xfrm>
+            <a:off x="640080" y="1874520"/>
+            <a:ext cx="5349240" cy="1554480"/>
           </a:xfrm>
           <a:prstGeom prst="roundRect">
             <a:avLst>
-              <a:gd name="adj" fmla="val 2667"/>
+              <a:gd name="adj" fmla="val 4706"/>
             </a:avLst>
           </a:prstGeom>
           <a:solidFill>
@@ -2618,14 +2668,14 @@
       </p:sp>
       <p:sp>
         <p:nvSpPr>
-          <p:cNvPr id="5" name="Shape 3"/>
-          <p:cNvSpPr/>
-          <p:nvPr/>
-        </p:nvSpPr>
-        <p:spPr>
-          <a:xfrm>
-            <a:off x="960120" y="2057400"/>
-            <a:ext cx="548640" cy="548640"/>
+          <p:cNvPr id="4" name="Shape 2"/>
+          <p:cNvSpPr/>
+          <p:nvPr/>
+        </p:nvSpPr>
+        <p:spPr>
+          <a:xfrm>
+            <a:off x="960120" y="2148840"/>
+            <a:ext cx="502920" cy="502920"/>
           </a:xfrm>
           <a:prstGeom prst="ellipse">
             <a:avLst/>
@@ -2638,7 +2688,7 @@
       </p:sp>
       <p:pic>
         <p:nvPicPr>
-          <p:cNvPr id="6" name="Image 0" descr="preencoded.png">    </p:cNvPr>
+          <p:cNvPr id="5" name="Image 0" descr="preencoded.png">    </p:cNvPr>
           <p:cNvPicPr>
             <a:picLocks noChangeAspect="1"/>
           </p:cNvPicPr>
@@ -2652,8 +2702,8 @@
         </p:blipFill>
         <p:spPr>
           <a:xfrm>
-            <a:off x="1097280" y="2194560"/>
-            <a:ext cx="274320" cy="274320"/>
+            <a:off x="1085850" y="2274570"/>
+            <a:ext cx="251460" cy="251460"/>
           </a:xfrm>
           <a:prstGeom prst="rect">
             <a:avLst/>
@@ -2662,14 +2712,14 @@
       </p:pic>
       <p:sp>
         <p:nvSpPr>
-          <p:cNvPr id="7" name="Text 4"/>
-          <p:cNvSpPr/>
-          <p:nvPr/>
-        </p:nvSpPr>
-        <p:spPr>
-          <a:xfrm>
-            <a:off x="1691640" y="2130552"/>
-            <a:ext cx="4114800" cy="411480"/>
+          <p:cNvPr id="6" name="Text 3"/>
+          <p:cNvSpPr/>
+          <p:nvPr/>
+        </p:nvSpPr>
+        <p:spPr>
+          <a:xfrm>
+            <a:off x="1600200" y="2130552"/>
+            <a:ext cx="4160520" cy="457200"/>
           </a:xfrm>
           <a:prstGeom prst="rect">
             <a:avLst/>
@@ -2693,7 +2743,7 @@
                 <a:ea typeface="Calibri" pitchFamily="34" charset="-122"/>
                 <a:cs typeface="Calibri" pitchFamily="34" charset="-120"/>
               </a:rPr>
-              <a:t>What we considered</a:t>
+              <a:t>Keyword retrieval</a:t>
             </a:r>
             <a:endParaRPr lang="en-US" sz="1700" dirty="0"/>
           </a:p>
@@ -2701,14 +2751,14 @@
       </p:sp>
       <p:sp>
         <p:nvSpPr>
-          <p:cNvPr id="8" name="Text 5"/>
-          <p:cNvSpPr/>
-          <p:nvPr/>
-        </p:nvSpPr>
-        <p:spPr>
-          <a:xfrm>
-            <a:off x="960120" y="2788920"/>
-            <a:ext cx="4754880" cy="1280160"/>
+          <p:cNvPr id="7" name="Text 4"/>
+          <p:cNvSpPr/>
+          <p:nvPr/>
+        </p:nvSpPr>
+        <p:spPr>
+          <a:xfrm>
+            <a:off x="960120" y="2660904"/>
+            <a:ext cx="4709160" cy="640080"/>
           </a:xfrm>
           <a:prstGeom prst="rect">
             <a:avLst/>
@@ -2721,40 +2771,37 @@
           <a:lstStyle/>
           <a:p>
             <a:pPr indent="0" marL="0">
-              <a:lnSpc>
-                <a:spcPct val="112000"/>
-              </a:lnSpc>
               <a:buNone/>
             </a:pPr>
             <a:r>
-              <a:rPr lang="en-US" sz="1450" dirty="0">
-                <a:solidFill>
-                  <a:srgbClr val="0F172A"/>
+              <a:rPr lang="en-US" sz="1400" dirty="0">
+                <a:solidFill>
+                  <a:srgbClr val="64748B"/>
                 </a:solidFill>
                 <a:latin typeface="Calibri" pitchFamily="34" charset="0"/>
                 <a:ea typeface="Calibri" pitchFamily="34" charset="-122"/>
                 <a:cs typeface="Calibri" pitchFamily="34" charset="-120"/>
               </a:rPr>
-              <a:t>A supervised model: for example, to route a claim to the right policy section, or to predict the edit action (allow, deny, flag) directly from text.</a:t>
-            </a:r>
-            <a:endParaRPr lang="en-US" sz="1450" dirty="0"/>
-          </a:p>
-        </p:txBody>
-      </p:sp>
-      <p:sp>
-        <p:nvSpPr>
-          <p:cNvPr id="9" name="Shape 6"/>
-          <p:cNvSpPr/>
-          <p:nvPr/>
-        </p:nvSpPr>
-        <p:spPr>
-          <a:xfrm>
-            <a:off x="6172200" y="1737360"/>
-            <a:ext cx="5349240" cy="2743200"/>
+              <a:t>Uses keyword matching today; semantic embeddings are the next upgrade.</a:t>
+            </a:r>
+            <a:endParaRPr lang="en-US" sz="1400" dirty="0"/>
+          </a:p>
+        </p:txBody>
+      </p:sp>
+      <p:sp>
+        <p:nvSpPr>
+          <p:cNvPr id="8" name="Shape 5"/>
+          <p:cNvSpPr/>
+          <p:nvPr/>
+        </p:nvSpPr>
+        <p:spPr>
+          <a:xfrm>
+            <a:off x="6355080" y="1874520"/>
+            <a:ext cx="5349240" cy="1554480"/>
           </a:xfrm>
           <a:prstGeom prst="roundRect">
             <a:avLst>
-              <a:gd name="adj" fmla="val 2667"/>
+              <a:gd name="adj" fmla="val 4706"/>
             </a:avLst>
           </a:prstGeom>
           <a:solidFill>
@@ -2777,6 +2824,743 @@
       </p:sp>
       <p:sp>
         <p:nvSpPr>
+          <p:cNvPr id="9" name="Shape 6"/>
+          <p:cNvSpPr/>
+          <p:nvPr/>
+        </p:nvSpPr>
+        <p:spPr>
+          <a:xfrm>
+            <a:off x="6675120" y="2148840"/>
+            <a:ext cx="502920" cy="502920"/>
+          </a:xfrm>
+          <a:prstGeom prst="ellipse">
+            <a:avLst/>
+          </a:prstGeom>
+          <a:solidFill>
+            <a:srgbClr val="0F766E"/>
+          </a:solidFill>
+          <a:ln/>
+        </p:spPr>
+      </p:sp>
+      <p:pic>
+        <p:nvPicPr>
+          <p:cNvPr id="10" name="Image 1" descr="preencoded.png">    </p:cNvPr>
+          <p:cNvPicPr>
+            <a:picLocks noChangeAspect="1"/>
+          </p:cNvPicPr>
+          <p:nvPr/>
+        </p:nvPicPr>
+        <p:blipFill>
+          <a:blip r:embed="rId2"/>
+          <a:stretch>
+            <a:fillRect/>
+          </a:stretch>
+        </p:blipFill>
+        <p:spPr>
+          <a:xfrm>
+            <a:off x="6800850" y="2274570"/>
+            <a:ext cx="251460" cy="251460"/>
+          </a:xfrm>
+          <a:prstGeom prst="rect">
+            <a:avLst/>
+          </a:prstGeom>
+        </p:spPr>
+      </p:pic>
+      <p:sp>
+        <p:nvSpPr>
+          <p:cNvPr id="11" name="Text 7"/>
+          <p:cNvSpPr/>
+          <p:nvPr/>
+        </p:nvSpPr>
+        <p:spPr>
+          <a:xfrm>
+            <a:off x="7315200" y="2130552"/>
+            <a:ext cx="4160520" cy="457200"/>
+          </a:xfrm>
+          <a:prstGeom prst="rect">
+            <a:avLst/>
+          </a:prstGeom>
+          <a:noFill/>
+          <a:ln/>
+        </p:spPr>
+        <p:txBody>
+          <a:bodyPr wrap="square" lIns="0" tIns="0" rIns="0" bIns="0" rtlCol="0" anchor="ctr"/>
+          <a:lstStyle/>
+          <a:p>
+            <a:pPr indent="0" marL="0">
+              <a:buNone/>
+            </a:pPr>
+            <a:r>
+              <a:rPr lang="en-US" sz="1700" b="1" dirty="0">
+                <a:solidFill>
+                  <a:srgbClr val="0F766E"/>
+                </a:solidFill>
+                <a:latin typeface="Calibri" pitchFamily="34" charset="0"/>
+                <a:ea typeface="Calibri" pitchFamily="34" charset="-122"/>
+                <a:cs typeface="Calibri" pitchFamily="34" charset="-120"/>
+              </a:rPr>
+              <a:t>Small evaluation set</a:t>
+            </a:r>
+            <a:endParaRPr lang="en-US" sz="1700" dirty="0"/>
+          </a:p>
+        </p:txBody>
+      </p:sp>
+      <p:sp>
+        <p:nvSpPr>
+          <p:cNvPr id="12" name="Text 8"/>
+          <p:cNvSpPr/>
+          <p:nvPr/>
+        </p:nvSpPr>
+        <p:spPr>
+          <a:xfrm>
+            <a:off x="6675120" y="2660904"/>
+            <a:ext cx="4709160" cy="640080"/>
+          </a:xfrm>
+          <a:prstGeom prst="rect">
+            <a:avLst/>
+          </a:prstGeom>
+          <a:noFill/>
+          <a:ln/>
+        </p:spPr>
+        <p:txBody>
+          <a:bodyPr wrap="square" lIns="0" tIns="0" rIns="0" bIns="0" rtlCol="0" anchor="t"/>
+          <a:lstStyle/>
+          <a:p>
+            <a:pPr indent="0" marL="0">
+              <a:buNone/>
+            </a:pPr>
+            <a:r>
+              <a:rPr lang="en-US" sz="1400" dirty="0">
+                <a:solidFill>
+                  <a:srgbClr val="64748B"/>
+                </a:solidFill>
+                <a:latin typeface="Calibri" pitchFamily="34" charset="0"/>
+                <a:ea typeface="Calibri" pitchFamily="34" charset="-122"/>
+                <a:cs typeface="Calibri" pitchFamily="34" charset="-120"/>
+              </a:rPr>
+              <a:t>Seven labeled provisions: a feasibility signal, not a production accuracy claim.</a:t>
+            </a:r>
+            <a:endParaRPr lang="en-US" sz="1400" dirty="0"/>
+          </a:p>
+        </p:txBody>
+      </p:sp>
+      <p:sp>
+        <p:nvSpPr>
+          <p:cNvPr id="13" name="Shape 9"/>
+          <p:cNvSpPr/>
+          <p:nvPr/>
+        </p:nvSpPr>
+        <p:spPr>
+          <a:xfrm>
+            <a:off x="640080" y="3657600"/>
+            <a:ext cx="5349240" cy="1554480"/>
+          </a:xfrm>
+          <a:prstGeom prst="roundRect">
+            <a:avLst>
+              <a:gd name="adj" fmla="val 4706"/>
+            </a:avLst>
+          </a:prstGeom>
+          <a:solidFill>
+            <a:srgbClr val="FFFFFF"/>
+          </a:solidFill>
+          <a:ln w="12700">
+            <a:solidFill>
+              <a:srgbClr val="E2E8F0"/>
+            </a:solidFill>
+            <a:prstDash val="solid"/>
+          </a:ln>
+          <a:effectLst>
+            <a:outerShdw sx="100000" sy="100000" kx="0" ky="0" algn="bl" rotWithShape="0" blurRad="101600" dist="38100" dir="5400000">
+              <a:srgbClr val="0F172A">
+                <a:alpha val="10000"/>
+              </a:srgbClr>
+            </a:outerShdw>
+          </a:effectLst>
+        </p:spPr>
+      </p:sp>
+      <p:sp>
+        <p:nvSpPr>
+          <p:cNvPr id="14" name="Shape 10"/>
+          <p:cNvSpPr/>
+          <p:nvPr/>
+        </p:nvSpPr>
+        <p:spPr>
+          <a:xfrm>
+            <a:off x="960120" y="3931920"/>
+            <a:ext cx="502920" cy="502920"/>
+          </a:xfrm>
+          <a:prstGeom prst="ellipse">
+            <a:avLst/>
+          </a:prstGeom>
+          <a:solidFill>
+            <a:srgbClr val="0F766E"/>
+          </a:solidFill>
+          <a:ln/>
+        </p:spPr>
+      </p:sp>
+      <p:pic>
+        <p:nvPicPr>
+          <p:cNvPr id="15" name="Image 2" descr="preencoded.png">    </p:cNvPr>
+          <p:cNvPicPr>
+            <a:picLocks noChangeAspect="1"/>
+          </p:cNvPicPr>
+          <p:nvPr/>
+        </p:nvPicPr>
+        <p:blipFill>
+          <a:blip r:embed="rId3"/>
+          <a:stretch>
+            <a:fillRect/>
+          </a:stretch>
+        </p:blipFill>
+        <p:spPr>
+          <a:xfrm>
+            <a:off x="1085850" y="4057650"/>
+            <a:ext cx="251460" cy="251460"/>
+          </a:xfrm>
+          <a:prstGeom prst="rect">
+            <a:avLst/>
+          </a:prstGeom>
+        </p:spPr>
+      </p:pic>
+      <p:sp>
+        <p:nvSpPr>
+          <p:cNvPr id="16" name="Text 11"/>
+          <p:cNvSpPr/>
+          <p:nvPr/>
+        </p:nvSpPr>
+        <p:spPr>
+          <a:xfrm>
+            <a:off x="1600200" y="3913632"/>
+            <a:ext cx="4160520" cy="457200"/>
+          </a:xfrm>
+          <a:prstGeom prst="rect">
+            <a:avLst/>
+          </a:prstGeom>
+          <a:noFill/>
+          <a:ln/>
+        </p:spPr>
+        <p:txBody>
+          <a:bodyPr wrap="square" lIns="0" tIns="0" rIns="0" bIns="0" rtlCol="0" anchor="ctr"/>
+          <a:lstStyle/>
+          <a:p>
+            <a:pPr indent="0" marL="0">
+              <a:buNone/>
+            </a:pPr>
+            <a:r>
+              <a:rPr lang="en-US" sz="1700" b="1" dirty="0">
+                <a:solidFill>
+                  <a:srgbClr val="0F766E"/>
+                </a:solidFill>
+                <a:latin typeface="Calibri" pitchFamily="34" charset="0"/>
+                <a:ea typeface="Calibri" pitchFamily="34" charset="-122"/>
+                <a:cs typeface="Calibri" pitchFamily="34" charset="-120"/>
+              </a:rPr>
+              <a:t>Model-agnostic by design</a:t>
+            </a:r>
+            <a:endParaRPr lang="en-US" sz="1700" dirty="0"/>
+          </a:p>
+        </p:txBody>
+      </p:sp>
+      <p:sp>
+        <p:nvSpPr>
+          <p:cNvPr id="17" name="Text 12"/>
+          <p:cNvSpPr/>
+          <p:nvPr/>
+        </p:nvSpPr>
+        <p:spPr>
+          <a:xfrm>
+            <a:off x="960120" y="4443984"/>
+            <a:ext cx="4709160" cy="640080"/>
+          </a:xfrm>
+          <a:prstGeom prst="rect">
+            <a:avLst/>
+          </a:prstGeom>
+          <a:noFill/>
+          <a:ln/>
+        </p:spPr>
+        <p:txBody>
+          <a:bodyPr wrap="square" lIns="0" tIns="0" rIns="0" bIns="0" rtlCol="0" anchor="t"/>
+          <a:lstStyle/>
+          <a:p>
+            <a:pPr indent="0" marL="0">
+              <a:buNone/>
+            </a:pPr>
+            <a:r>
+              <a:rPr lang="en-US" sz="1400" dirty="0">
+                <a:solidFill>
+                  <a:srgbClr val="64748B"/>
+                </a:solidFill>
+                <a:latin typeface="Calibri" pitchFamily="34" charset="0"/>
+                <a:ea typeface="Calibri" pitchFamily="34" charset="-122"/>
+                <a:cs typeface="Calibri" pitchFamily="34" charset="-120"/>
+              </a:rPr>
+              <a:t>Ran on a free open model; the same pipeline runs on any production model.</a:t>
+            </a:r>
+            <a:endParaRPr lang="en-US" sz="1400" dirty="0"/>
+          </a:p>
+        </p:txBody>
+      </p:sp>
+      <p:sp>
+        <p:nvSpPr>
+          <p:cNvPr id="18" name="Shape 13"/>
+          <p:cNvSpPr/>
+          <p:nvPr/>
+        </p:nvSpPr>
+        <p:spPr>
+          <a:xfrm>
+            <a:off x="6355080" y="3657600"/>
+            <a:ext cx="5349240" cy="1554480"/>
+          </a:xfrm>
+          <a:prstGeom prst="roundRect">
+            <a:avLst>
+              <a:gd name="adj" fmla="val 4706"/>
+            </a:avLst>
+          </a:prstGeom>
+          <a:solidFill>
+            <a:srgbClr val="FFFFFF"/>
+          </a:solidFill>
+          <a:ln w="12700">
+            <a:solidFill>
+              <a:srgbClr val="E2E8F0"/>
+            </a:solidFill>
+            <a:prstDash val="solid"/>
+          </a:ln>
+          <a:effectLst>
+            <a:outerShdw sx="100000" sy="100000" kx="0" ky="0" algn="bl" rotWithShape="0" blurRad="101600" dist="38100" dir="5400000">
+              <a:srgbClr val="0F172A">
+                <a:alpha val="10000"/>
+              </a:srgbClr>
+            </a:outerShdw>
+          </a:effectLst>
+        </p:spPr>
+      </p:sp>
+      <p:sp>
+        <p:nvSpPr>
+          <p:cNvPr id="19" name="Shape 14"/>
+          <p:cNvSpPr/>
+          <p:nvPr/>
+        </p:nvSpPr>
+        <p:spPr>
+          <a:xfrm>
+            <a:off x="6675120" y="3931920"/>
+            <a:ext cx="502920" cy="502920"/>
+          </a:xfrm>
+          <a:prstGeom prst="ellipse">
+            <a:avLst/>
+          </a:prstGeom>
+          <a:solidFill>
+            <a:srgbClr val="0F766E"/>
+          </a:solidFill>
+          <a:ln/>
+        </p:spPr>
+      </p:sp>
+      <p:pic>
+        <p:nvPicPr>
+          <p:cNvPr id="20" name="Image 3" descr="preencoded.png">    </p:cNvPr>
+          <p:cNvPicPr>
+            <a:picLocks noChangeAspect="1"/>
+          </p:cNvPicPr>
+          <p:nvPr/>
+        </p:nvPicPr>
+        <p:blipFill>
+          <a:blip r:embed="rId4"/>
+          <a:stretch>
+            <a:fillRect/>
+          </a:stretch>
+        </p:blipFill>
+        <p:spPr>
+          <a:xfrm>
+            <a:off x="6800850" y="4057650"/>
+            <a:ext cx="251460" cy="251460"/>
+          </a:xfrm>
+          <a:prstGeom prst="rect">
+            <a:avLst/>
+          </a:prstGeom>
+        </p:spPr>
+      </p:pic>
+      <p:sp>
+        <p:nvSpPr>
+          <p:cNvPr id="21" name="Text 15"/>
+          <p:cNvSpPr/>
+          <p:nvPr/>
+        </p:nvSpPr>
+        <p:spPr>
+          <a:xfrm>
+            <a:off x="7315200" y="3913632"/>
+            <a:ext cx="4160520" cy="457200"/>
+          </a:xfrm>
+          <a:prstGeom prst="rect">
+            <a:avLst/>
+          </a:prstGeom>
+          <a:noFill/>
+          <a:ln/>
+        </p:spPr>
+        <p:txBody>
+          <a:bodyPr wrap="square" lIns="0" tIns="0" rIns="0" bIns="0" rtlCol="0" anchor="ctr"/>
+          <a:lstStyle/>
+          <a:p>
+            <a:pPr indent="0" marL="0">
+              <a:buNone/>
+            </a:pPr>
+            <a:r>
+              <a:rPr lang="en-US" sz="1700" b="1" dirty="0">
+                <a:solidFill>
+                  <a:srgbClr val="0F766E"/>
+                </a:solidFill>
+                <a:latin typeface="Calibri" pitchFamily="34" charset="0"/>
+                <a:ea typeface="Calibri" pitchFamily="34" charset="-122"/>
+                <a:cs typeface="Calibri" pitchFamily="34" charset="-120"/>
+              </a:rPr>
+              <a:t>Scope: one chapter</a:t>
+            </a:r>
+            <a:endParaRPr lang="en-US" sz="1700" dirty="0"/>
+          </a:p>
+        </p:txBody>
+      </p:sp>
+      <p:sp>
+        <p:nvSpPr>
+          <p:cNvPr id="22" name="Text 16"/>
+          <p:cNvSpPr/>
+          <p:nvPr/>
+        </p:nvSpPr>
+        <p:spPr>
+          <a:xfrm>
+            <a:off x="6675120" y="4443984"/>
+            <a:ext cx="4709160" cy="640080"/>
+          </a:xfrm>
+          <a:prstGeom prst="rect">
+            <a:avLst/>
+          </a:prstGeom>
+          <a:noFill/>
+          <a:ln/>
+        </p:spPr>
+        <p:txBody>
+          <a:bodyPr wrap="square" lIns="0" tIns="0" rIns="0" bIns="0" rtlCol="0" anchor="t"/>
+          <a:lstStyle/>
+          <a:p>
+            <a:pPr indent="0" marL="0">
+              <a:buNone/>
+            </a:pPr>
+            <a:r>
+              <a:rPr lang="en-US" sz="1400" dirty="0">
+                <a:solidFill>
+                  <a:srgbClr val="64748B"/>
+                </a:solidFill>
+                <a:latin typeface="Calibri" pitchFamily="34" charset="0"/>
+                <a:ea typeface="Calibri" pitchFamily="34" charset="-122"/>
+                <a:cs typeface="Calibri" pitchFamily="34" charset="-120"/>
+              </a:rPr>
+              <a:t>Demonstrated on Chapter 1 of the NCCI manual; the same approach generalizes to the full manual and other policy sources.</a:t>
+            </a:r>
+            <a:endParaRPr lang="en-US" sz="1400" dirty="0"/>
+          </a:p>
+        </p:txBody>
+      </p:sp>
+    </p:spTree>
+  </p:cSld>
+  <p:clrMapOvr>
+    <a:masterClrMapping/>
+  </p:clrMapOvr>
+</p:sld>
+</file>
+
+<file path=ppt/slides/slide11.xml><?xml version="1.0" encoding="utf-8"?>
+<p:sld xmlns:a="http://schemas.openxmlformats.org/drawingml/2006/main" xmlns:r="http://schemas.openxmlformats.org/officeDocument/2006/relationships" xmlns:p="http://schemas.openxmlformats.org/presentationml/2006/main">
+  <p:cSld name="Slide 11">
+    <p:bg>
+      <p:bgPr>
+        <a:solidFill>
+          <a:srgbClr val="FFFFFF"/>
+        </a:solidFill>
+      </p:bgPr>
+    </p:bg>
+    <p:spTree>
+      <p:nvGrpSpPr>
+        <p:cNvPr id="1" name=""/>
+        <p:cNvGrpSpPr/>
+        <p:nvPr/>
+      </p:nvGrpSpPr>
+      <p:grpSpPr>
+        <a:xfrm>
+          <a:off x="0" y="0"/>
+          <a:ext cx="0" cy="0"/>
+          <a:chOff x="0" y="0"/>
+          <a:chExt cx="0" cy="0"/>
+        </a:xfrm>
+      </p:grpSpPr>
+      <p:sp>
+        <p:nvSpPr>
+          <p:cNvPr id="2" name="Text 0"/>
+          <p:cNvSpPr/>
+          <p:nvPr/>
+        </p:nvSpPr>
+        <p:spPr>
+          <a:xfrm>
+            <a:off x="640080" y="411480"/>
+            <a:ext cx="10881360" cy="640080"/>
+          </a:xfrm>
+          <a:prstGeom prst="rect">
+            <a:avLst/>
+          </a:prstGeom>
+          <a:noFill/>
+          <a:ln/>
+        </p:spPr>
+        <p:txBody>
+          <a:bodyPr wrap="square" lIns="0" tIns="0" rIns="0" bIns="0" rtlCol="0" anchor="ctr"/>
+          <a:lstStyle/>
+          <a:p>
+            <a:pPr indent="0" marL="0">
+              <a:buNone/>
+            </a:pPr>
+            <a:r>
+              <a:rPr lang="en-US" sz="3000" b="1" dirty="0">
+                <a:solidFill>
+                  <a:srgbClr val="0F172A"/>
+                </a:solidFill>
+                <a:latin typeface="Cambria" pitchFamily="34" charset="0"/>
+                <a:ea typeface="Cambria" pitchFamily="34" charset="-122"/>
+                <a:cs typeface="Cambria" pitchFamily="34" charset="-120"/>
+              </a:rPr>
+              <a:t>A deliberate choice: we did not train a model (yet)</a:t>
+            </a:r>
+            <a:endParaRPr lang="en-US" sz="3000" dirty="0"/>
+          </a:p>
+        </p:txBody>
+      </p:sp>
+      <p:sp>
+        <p:nvSpPr>
+          <p:cNvPr id="3" name="Text 1"/>
+          <p:cNvSpPr/>
+          <p:nvPr/>
+        </p:nvSpPr>
+        <p:spPr>
+          <a:xfrm>
+            <a:off x="640080" y="1051560"/>
+            <a:ext cx="10881360" cy="365760"/>
+          </a:xfrm>
+          <a:prstGeom prst="rect">
+            <a:avLst/>
+          </a:prstGeom>
+          <a:noFill/>
+          <a:ln/>
+        </p:spPr>
+        <p:txBody>
+          <a:bodyPr wrap="square" lIns="0" tIns="0" rIns="0" bIns="0" rtlCol="0" anchor="ctr"/>
+          <a:lstStyle/>
+          <a:p>
+            <a:pPr indent="0" marL="0">
+              <a:buNone/>
+            </a:pPr>
+            <a:r>
+              <a:rPr lang="en-US" sz="1500" dirty="0">
+                <a:solidFill>
+                  <a:srgbClr val="64748B"/>
+                </a:solidFill>
+                <a:latin typeface="Calibri" pitchFamily="34" charset="0"/>
+                <a:ea typeface="Calibri" pitchFamily="34" charset="-122"/>
+                <a:cs typeface="Calibri" pitchFamily="34" charset="-120"/>
+              </a:rPr>
+              <a:t>Knowing when not to reach for the heavier tool</a:t>
+            </a:r>
+            <a:endParaRPr lang="en-US" sz="1500" dirty="0"/>
+          </a:p>
+        </p:txBody>
+      </p:sp>
+      <p:sp>
+        <p:nvSpPr>
+          <p:cNvPr id="4" name="Shape 2"/>
+          <p:cNvSpPr/>
+          <p:nvPr/>
+        </p:nvSpPr>
+        <p:spPr>
+          <a:xfrm>
+            <a:off x="640080" y="1737360"/>
+            <a:ext cx="5349240" cy="2743200"/>
+          </a:xfrm>
+          <a:prstGeom prst="roundRect">
+            <a:avLst>
+              <a:gd name="adj" fmla="val 2667"/>
+            </a:avLst>
+          </a:prstGeom>
+          <a:solidFill>
+            <a:srgbClr val="FFFFFF"/>
+          </a:solidFill>
+          <a:ln w="12700">
+            <a:solidFill>
+              <a:srgbClr val="E2E8F0"/>
+            </a:solidFill>
+            <a:prstDash val="solid"/>
+          </a:ln>
+          <a:effectLst>
+            <a:outerShdw sx="100000" sy="100000" kx="0" ky="0" algn="bl" rotWithShape="0" blurRad="101600" dist="38100" dir="5400000">
+              <a:srgbClr val="0F172A">
+                <a:alpha val="10000"/>
+              </a:srgbClr>
+            </a:outerShdw>
+          </a:effectLst>
+        </p:spPr>
+      </p:sp>
+      <p:sp>
+        <p:nvSpPr>
+          <p:cNvPr id="5" name="Shape 3"/>
+          <p:cNvSpPr/>
+          <p:nvPr/>
+        </p:nvSpPr>
+        <p:spPr>
+          <a:xfrm>
+            <a:off x="960120" y="2057400"/>
+            <a:ext cx="548640" cy="548640"/>
+          </a:xfrm>
+          <a:prstGeom prst="ellipse">
+            <a:avLst/>
+          </a:prstGeom>
+          <a:solidFill>
+            <a:srgbClr val="0F766E"/>
+          </a:solidFill>
+          <a:ln/>
+        </p:spPr>
+      </p:sp>
+      <p:pic>
+        <p:nvPicPr>
+          <p:cNvPr id="6" name="Image 0" descr="preencoded.png">    </p:cNvPr>
+          <p:cNvPicPr>
+            <a:picLocks noChangeAspect="1"/>
+          </p:cNvPicPr>
+          <p:nvPr/>
+        </p:nvPicPr>
+        <p:blipFill>
+          <a:blip r:embed="rId1"/>
+          <a:stretch>
+            <a:fillRect/>
+          </a:stretch>
+        </p:blipFill>
+        <p:spPr>
+          <a:xfrm>
+            <a:off x="1097280" y="2194560"/>
+            <a:ext cx="274320" cy="274320"/>
+          </a:xfrm>
+          <a:prstGeom prst="rect">
+            <a:avLst/>
+          </a:prstGeom>
+        </p:spPr>
+      </p:pic>
+      <p:sp>
+        <p:nvSpPr>
+          <p:cNvPr id="7" name="Text 4"/>
+          <p:cNvSpPr/>
+          <p:nvPr/>
+        </p:nvSpPr>
+        <p:spPr>
+          <a:xfrm>
+            <a:off x="1691640" y="2130552"/>
+            <a:ext cx="4114800" cy="411480"/>
+          </a:xfrm>
+          <a:prstGeom prst="rect">
+            <a:avLst/>
+          </a:prstGeom>
+          <a:noFill/>
+          <a:ln/>
+        </p:spPr>
+        <p:txBody>
+          <a:bodyPr wrap="square" lIns="0" tIns="0" rIns="0" bIns="0" rtlCol="0" anchor="ctr"/>
+          <a:lstStyle/>
+          <a:p>
+            <a:pPr indent="0" marL="0">
+              <a:buNone/>
+            </a:pPr>
+            <a:r>
+              <a:rPr lang="en-US" sz="1700" b="1" dirty="0">
+                <a:solidFill>
+                  <a:srgbClr val="0F766E"/>
+                </a:solidFill>
+                <a:latin typeface="Calibri" pitchFamily="34" charset="0"/>
+                <a:ea typeface="Calibri" pitchFamily="34" charset="-122"/>
+                <a:cs typeface="Calibri" pitchFamily="34" charset="-120"/>
+              </a:rPr>
+              <a:t>What we considered</a:t>
+            </a:r>
+            <a:endParaRPr lang="en-US" sz="1700" dirty="0"/>
+          </a:p>
+        </p:txBody>
+      </p:sp>
+      <p:sp>
+        <p:nvSpPr>
+          <p:cNvPr id="8" name="Text 5"/>
+          <p:cNvSpPr/>
+          <p:nvPr/>
+        </p:nvSpPr>
+        <p:spPr>
+          <a:xfrm>
+            <a:off x="960120" y="2788920"/>
+            <a:ext cx="4754880" cy="1280160"/>
+          </a:xfrm>
+          <a:prstGeom prst="rect">
+            <a:avLst/>
+          </a:prstGeom>
+          <a:noFill/>
+          <a:ln/>
+        </p:spPr>
+        <p:txBody>
+          <a:bodyPr wrap="square" lIns="0" tIns="0" rIns="0" bIns="0" rtlCol="0" anchor="t"/>
+          <a:lstStyle/>
+          <a:p>
+            <a:pPr indent="0" marL="0">
+              <a:lnSpc>
+                <a:spcPct val="112000"/>
+              </a:lnSpc>
+              <a:buNone/>
+            </a:pPr>
+            <a:r>
+              <a:rPr lang="en-US" sz="1450" dirty="0">
+                <a:solidFill>
+                  <a:srgbClr val="0F172A"/>
+                </a:solidFill>
+                <a:latin typeface="Calibri" pitchFamily="34" charset="0"/>
+                <a:ea typeface="Calibri" pitchFamily="34" charset="-122"/>
+                <a:cs typeface="Calibri" pitchFamily="34" charset="-120"/>
+              </a:rPr>
+              <a:t>A supervised model: for example, to route a claim to the right policy section, or to predict the edit action (allow, deny, flag) directly from text.</a:t>
+            </a:r>
+            <a:endParaRPr lang="en-US" sz="1450" dirty="0"/>
+          </a:p>
+        </p:txBody>
+      </p:sp>
+      <p:sp>
+        <p:nvSpPr>
+          <p:cNvPr id="9" name="Shape 6"/>
+          <p:cNvSpPr/>
+          <p:nvPr/>
+        </p:nvSpPr>
+        <p:spPr>
+          <a:xfrm>
+            <a:off x="6172200" y="1737360"/>
+            <a:ext cx="5349240" cy="2743200"/>
+          </a:xfrm>
+          <a:prstGeom prst="roundRect">
+            <a:avLst>
+              <a:gd name="adj" fmla="val 2667"/>
+            </a:avLst>
+          </a:prstGeom>
+          <a:solidFill>
+            <a:srgbClr val="FFFFFF"/>
+          </a:solidFill>
+          <a:ln w="12700">
+            <a:solidFill>
+              <a:srgbClr val="E2E8F0"/>
+            </a:solidFill>
+            <a:prstDash val="solid"/>
+          </a:ln>
+          <a:effectLst>
+            <a:outerShdw sx="100000" sy="100000" kx="0" ky="0" algn="bl" rotWithShape="0" blurRad="101600" dist="38100" dir="5400000">
+              <a:srgbClr val="0F172A">
+                <a:alpha val="10000"/>
+              </a:srgbClr>
+            </a:outerShdw>
+          </a:effectLst>
+        </p:spPr>
+      </p:sp>
+      <p:sp>
+        <p:nvSpPr>
           <p:cNvPr id="10" name="Shape 7"/>
           <p:cNvSpPr/>
           <p:nvPr/>
@@ -3131,9 +3915,9 @@
 </p:sld>
 </file>
 
-<file path=ppt/slides/slide11.xml><?xml version="1.0" encoding="utf-8"?>
+<file path=ppt/slides/slide12.xml><?xml version="1.0" encoding="utf-8"?>
 <p:sld xmlns:a="http://schemas.openxmlformats.org/drawingml/2006/main" xmlns:r="http://schemas.openxmlformats.org/officeDocument/2006/relationships" xmlns:p="http://schemas.openxmlformats.org/presentationml/2006/main">
-  <p:cSld name="Slide 11">
+  <p:cSld name="Slide 12">
     <p:bg>
       <p:bgPr>
         <a:solidFill>
@@ -3202,8 +3986,8 @@
         </p:nvSpPr>
         <p:spPr>
           <a:xfrm>
-            <a:off x="822960" y="2286000"/>
-            <a:ext cx="10058400" cy="1645920"/>
+            <a:off x="822960" y="2057400"/>
+            <a:ext cx="10058400" cy="1371600"/>
           </a:xfrm>
           <a:prstGeom prst="rect">
             <a:avLst/>
@@ -3217,12 +4001,12 @@
           <a:p>
             <a:pPr indent="0" marL="0">
               <a:lnSpc>
-                <a:spcPct val="115000"/>
+                <a:spcPct val="112000"/>
               </a:lnSpc>
               <a:buNone/>
             </a:pPr>
             <a:r>
-              <a:rPr lang="en-US" sz="2600" dirty="0">
+              <a:rPr lang="en-US" sz="2400" dirty="0">
                 <a:solidFill>
                   <a:srgbClr val="FFFFFF"/>
                 </a:solidFill>
@@ -3232,7 +4016,7 @@
               </a:rPr>
               <a:t>Pilot an agent-assisted policy-to-rules workflow: subject-matter experts verify machine-extracted, source-cited edits instead of authoring them by hand.</a:t>
             </a:r>
-            <a:endParaRPr lang="en-US" sz="2600" dirty="0"/>
+            <a:endParaRPr lang="en-US" sz="2400" dirty="0"/>
           </a:p>
         </p:txBody>
       </p:sp>
@@ -3244,8 +4028,8 @@
         </p:nvSpPr>
         <p:spPr>
           <a:xfrm>
-            <a:off x="822960" y="4114800"/>
-            <a:ext cx="10058400" cy="548640"/>
+            <a:off x="822960" y="3611880"/>
+            <a:ext cx="10058400" cy="868680"/>
           </a:xfrm>
           <a:prstGeom prst="rect">
             <a:avLst/>
@@ -3258,26 +4042,68 @@
           <a:lstStyle/>
           <a:p>
             <a:pPr indent="0" marL="0">
+              <a:lnSpc>
+                <a:spcPct val="110000"/>
+              </a:lnSpc>
               <a:buNone/>
             </a:pPr>
             <a:r>
-              <a:rPr lang="en-US" sz="1800" i="1" dirty="0">
-                <a:solidFill>
-                  <a:srgbClr val="9FE7DC"/>
+              <a:rPr lang="en-US" sz="1600" dirty="0">
+                <a:solidFill>
+                  <a:srgbClr val="C9EFE8"/>
                 </a:solidFill>
                 <a:latin typeface="Calibri" pitchFamily="34" charset="0"/>
                 <a:ea typeface="Calibri" pitchFamily="34" charset="-122"/>
                 <a:cs typeface="Calibri" pitchFamily="34" charset="-120"/>
               </a:rPr>
+              <a:t>The payoff: expert time shifts from writing rules to checking them, shortening the path from a published guideline change to a live, audited claim edit.</a:t>
+            </a:r>
+            <a:endParaRPr lang="en-US" sz="1600" dirty="0"/>
+          </a:p>
+        </p:txBody>
+      </p:sp>
+      <p:sp>
+        <p:nvSpPr>
+          <p:cNvPr id="5" name="Text 3"/>
+          <p:cNvSpPr/>
+          <p:nvPr/>
+        </p:nvSpPr>
+        <p:spPr>
+          <a:xfrm>
+            <a:off x="822960" y="4572000"/>
+            <a:ext cx="10058400" cy="457200"/>
+          </a:xfrm>
+          <a:prstGeom prst="rect">
+            <a:avLst/>
+          </a:prstGeom>
+          <a:noFill/>
+          <a:ln/>
+        </p:spPr>
+        <p:txBody>
+          <a:bodyPr wrap="square" lIns="0" tIns="0" rIns="0" bIns="0" rtlCol="0" anchor="ctr"/>
+          <a:lstStyle/>
+          <a:p>
+            <a:pPr indent="0" marL="0">
+              <a:buNone/>
+            </a:pPr>
+            <a:r>
+              <a:rPr lang="en-US" sz="1600" i="1" dirty="0">
+                <a:solidFill>
+                  <a:srgbClr val="9FE7DC"/>
+                </a:solidFill>
+                <a:latin typeface="Calibri" pitchFamily="34" charset="0"/>
+                <a:ea typeface="Calibri" pitchFamily="34" charset="-122"/>
+                <a:cs typeface="Calibri" pitchFamily="34" charset="-120"/>
+              </a:rPr>
               <a:t>Accelerate the work. Hold the line on trust.</a:t>
             </a:r>
-            <a:endParaRPr lang="en-US" sz="1800" dirty="0"/>
+            <a:endParaRPr lang="en-US" sz="1600" dirty="0"/>
           </a:p>
         </p:txBody>
       </p:sp>
       <p:pic>
         <p:nvPicPr>
-          <p:cNvPr id="5" name="Image 0" descr="preencoded.png">    </p:cNvPr>
+          <p:cNvPr id="6" name="Image 0" descr="preencoded.png">    </p:cNvPr>
           <p:cNvPicPr>
             <a:picLocks noChangeAspect="1"/>
           </p:cNvPicPr>
@@ -3301,7 +4127,7 @@
       </p:pic>
       <p:sp>
         <p:nvSpPr>
-          <p:cNvPr id="6" name="Text 3"/>
+          <p:cNvPr id="7" name="Text 4"/>
           <p:cNvSpPr/>
           <p:nvPr/>
         </p:nvSpPr>
@@ -3340,7 +4166,7 @@
       </p:sp>
       <p:pic>
         <p:nvPicPr>
-          <p:cNvPr id="7" name="Image 1" descr="preencoded.png">    </p:cNvPr>
+          <p:cNvPr id="8" name="Image 1" descr="preencoded.png">    </p:cNvPr>
           <p:cNvPicPr>
             <a:picLocks noChangeAspect="1"/>
           </p:cNvPicPr>
@@ -3364,7 +4190,7 @@
       </p:pic>
       <p:sp>
         <p:nvSpPr>
-          <p:cNvPr id="8" name="Text 4"/>
+          <p:cNvPr id="9" name="Text 5"/>
           <p:cNvSpPr/>
           <p:nvPr/>
         </p:nvSpPr>
@@ -3403,7 +4229,7 @@
       </p:sp>
       <p:sp>
         <p:nvSpPr>
-          <p:cNvPr id="9" name="Text 5"/>
+          <p:cNvPr id="10" name="Text 6"/>
           <p:cNvSpPr/>
           <p:nvPr/>
         </p:nvSpPr>
@@ -5761,24 +6587,236 @@
           </a:p>
         </p:txBody>
       </p:sp>
-      <p:sp>
-        <p:nvSpPr>
-          <p:cNvPr id="3" name="Shape 1"/>
-          <p:cNvSpPr/>
-          <p:nvPr/>
-        </p:nvSpPr>
-        <p:spPr>
-          <a:xfrm>
-            <a:off x="640080" y="1828800"/>
-            <a:ext cx="5303520" cy="2743200"/>
+      <p:pic>
+        <p:nvPicPr>
+          <p:cNvPr id="3" name="Image 0" descr="/mnt/user-data/outputs/cotiviti-policy-to-rules/assets/screenshot_grounding.png">    </p:cNvPr>
+          <p:cNvPicPr>
+            <a:picLocks noChangeAspect="1"/>
+          </p:cNvPicPr>
+          <p:nvPr/>
+        </p:nvPicPr>
+        <p:blipFill>
+          <a:blip r:embed="rId1"/>
+          <a:stretch>
+            <a:fillRect/>
+          </a:stretch>
+        </p:blipFill>
+        <p:spPr>
+          <a:xfrm>
+            <a:off x="1417320" y="1417320"/>
+            <a:ext cx="9326880" cy="4233672"/>
+          </a:xfrm>
+          <a:prstGeom prst="rect">
+            <a:avLst/>
+          </a:prstGeom>
+        </p:spPr>
+      </p:pic>
+      <p:sp>
+        <p:nvSpPr>
+          <p:cNvPr id="4" name="Shape 1"/>
+          <p:cNvSpPr/>
+          <p:nvPr/>
+        </p:nvSpPr>
+        <p:spPr>
+          <a:xfrm>
+            <a:off x="1417320" y="1417320"/>
+            <a:ext cx="9326880" cy="4233672"/>
+          </a:xfrm>
+          <a:prstGeom prst="rect">
+            <a:avLst/>
+          </a:prstGeom>
+          <a:solidFill>
+            <a:srgbClr val="FFFFFF">
+              <a:alpha val="0"/>
+            </a:srgbClr>
+          </a:solidFill>
+          <a:ln w="12700">
+            <a:solidFill>
+              <a:srgbClr val="D9DEE5"/>
+            </a:solidFill>
+            <a:prstDash val="solid"/>
+          </a:ln>
+        </p:spPr>
+      </p:sp>
+      <p:sp>
+        <p:nvSpPr>
+          <p:cNvPr id="5" name="Text 2"/>
+          <p:cNvSpPr/>
+          <p:nvPr/>
+        </p:nvSpPr>
+        <p:spPr>
+          <a:xfrm>
+            <a:off x="640080" y="5897880"/>
+            <a:ext cx="10881360" cy="548640"/>
+          </a:xfrm>
+          <a:prstGeom prst="rect">
+            <a:avLst/>
+          </a:prstGeom>
+          <a:noFill/>
+          <a:ln/>
+        </p:spPr>
+        <p:txBody>
+          <a:bodyPr wrap="square" lIns="0" tIns="0" rIns="0" bIns="0" rtlCol="0" anchor="ctr"/>
+          <a:lstStyle/>
+          <a:p>
+            <a:pPr algn="ctr" indent="0" marL="0">
+              <a:buNone/>
+            </a:pPr>
+            <a:r>
+              <a:rPr lang="en-US" sz="1500" b="1" dirty="0">
+                <a:solidFill>
+                  <a:srgbClr val="0F766E"/>
+                </a:solidFill>
+                <a:latin typeface="Calibri" pitchFamily="34" charset="0"/>
+                <a:ea typeface="Calibri" pitchFamily="34" charset="-122"/>
+                <a:cs typeface="Calibri" pitchFamily="34" charset="-120"/>
+              </a:rPr>
+              <a:t>Green grounds, red flags. A hallucinated coding rule is a compliance failure, so every citation is verified against the policy text before a rule is trusted.</a:t>
+            </a:r>
+            <a:endParaRPr lang="en-US" sz="1500" dirty="0"/>
+          </a:p>
+        </p:txBody>
+      </p:sp>
+    </p:spTree>
+  </p:cSld>
+  <p:clrMapOvr>
+    <a:masterClrMapping/>
+  </p:clrMapOvr>
+</p:sld>
+</file>
+
+<file path=ppt/slides/slide7.xml><?xml version="1.0" encoding="utf-8"?>
+<p:sld xmlns:a="http://schemas.openxmlformats.org/drawingml/2006/main" xmlns:r="http://schemas.openxmlformats.org/officeDocument/2006/relationships" xmlns:p="http://schemas.openxmlformats.org/presentationml/2006/main">
+  <p:cSld name="Slide 7">
+    <p:bg>
+      <p:bgPr>
+        <a:solidFill>
+          <a:srgbClr val="FFFFFF"/>
+        </a:solidFill>
+      </p:bgPr>
+    </p:bg>
+    <p:spTree>
+      <p:nvGrpSpPr>
+        <p:cNvPr id="1" name=""/>
+        <p:cNvGrpSpPr/>
+        <p:nvPr/>
+      </p:nvGrpSpPr>
+      <p:grpSpPr>
+        <a:xfrm>
+          <a:off x="0" y="0"/>
+          <a:ext cx="0" cy="0"/>
+          <a:chOff x="0" y="0"/>
+          <a:chExt cx="0" cy="0"/>
+        </a:xfrm>
+      </p:grpSpPr>
+      <p:sp>
+        <p:nvSpPr>
+          <p:cNvPr id="2" name="Text 0"/>
+          <p:cNvSpPr/>
+          <p:nvPr/>
+        </p:nvSpPr>
+        <p:spPr>
+          <a:xfrm>
+            <a:off x="640080" y="411480"/>
+            <a:ext cx="10881360" cy="640080"/>
+          </a:xfrm>
+          <a:prstGeom prst="rect">
+            <a:avLst/>
+          </a:prstGeom>
+          <a:noFill/>
+          <a:ln/>
+        </p:spPr>
+        <p:txBody>
+          <a:bodyPr wrap="square" lIns="0" tIns="0" rIns="0" bIns="0" rtlCol="0" anchor="ctr"/>
+          <a:lstStyle/>
+          <a:p>
+            <a:pPr indent="0" marL="0">
+              <a:buNone/>
+            </a:pPr>
+            <a:r>
+              <a:rPr lang="en-US" sz="3000" b="1" dirty="0">
+                <a:solidFill>
+                  <a:srgbClr val="0F172A"/>
+                </a:solidFill>
+                <a:latin typeface="Cambria" pitchFamily="34" charset="0"/>
+                <a:ea typeface="Cambria" pitchFamily="34" charset="-122"/>
+                <a:cs typeface="Cambria" pitchFamily="34" charset="-120"/>
+              </a:rPr>
+              <a:t>Catching policy change before it breaks a rule</a:t>
+            </a:r>
+            <a:endParaRPr lang="en-US" sz="3000" dirty="0"/>
+          </a:p>
+        </p:txBody>
+      </p:sp>
+      <p:pic>
+        <p:nvPicPr>
+          <p:cNvPr id="3" name="Image 0" descr="/mnt/user-data/outputs/cotiviti-policy-to-rules/assets/screenshot_diff.png">    </p:cNvPr>
+          <p:cNvPicPr>
+            <a:picLocks noChangeAspect="1"/>
+          </p:cNvPicPr>
+          <p:nvPr/>
+        </p:nvPicPr>
+        <p:blipFill>
+          <a:blip r:embed="rId1"/>
+          <a:stretch>
+            <a:fillRect/>
+          </a:stretch>
+        </p:blipFill>
+        <p:spPr>
+          <a:xfrm>
+            <a:off x="640080" y="1554480"/>
+            <a:ext cx="5852160" cy="4471416"/>
+          </a:xfrm>
+          <a:prstGeom prst="rect">
+            <a:avLst/>
+          </a:prstGeom>
+        </p:spPr>
+      </p:pic>
+      <p:sp>
+        <p:nvSpPr>
+          <p:cNvPr id="4" name="Shape 1"/>
+          <p:cNvSpPr/>
+          <p:nvPr/>
+        </p:nvSpPr>
+        <p:spPr>
+          <a:xfrm>
+            <a:off x="640080" y="1554480"/>
+            <a:ext cx="5852160" cy="4471416"/>
+          </a:xfrm>
+          <a:prstGeom prst="rect">
+            <a:avLst/>
+          </a:prstGeom>
+          <a:solidFill>
+            <a:srgbClr val="FFFFFF">
+              <a:alpha val="0"/>
+            </a:srgbClr>
+          </a:solidFill>
+          <a:ln w="12700">
+            <a:solidFill>
+              <a:srgbClr val="D9DEE5"/>
+            </a:solidFill>
+            <a:prstDash val="solid"/>
+          </a:ln>
+        </p:spPr>
+      </p:sp>
+      <p:sp>
+        <p:nvSpPr>
+          <p:cNvPr id="5" name="Shape 2"/>
+          <p:cNvSpPr/>
+          <p:nvPr/>
+        </p:nvSpPr>
+        <p:spPr>
+          <a:xfrm>
+            <a:off x="6858000" y="1783080"/>
+            <a:ext cx="4663440" cy="3108960"/>
           </a:xfrm>
           <a:prstGeom prst="roundRect">
             <a:avLst>
-              <a:gd name="adj" fmla="val 2667"/>
+              <a:gd name="adj" fmla="val 2353"/>
             </a:avLst>
           </a:prstGeom>
           <a:solidFill>
-            <a:srgbClr val="FFFFFF"/>
+            <a:srgbClr val="E8F2F0"/>
           </a:solidFill>
           <a:ln w="12700">
             <a:solidFill>
@@ -5795,40 +6833,16 @@
           </a:effectLst>
         </p:spPr>
       </p:sp>
-      <p:pic>
-        <p:nvPicPr>
-          <p:cNvPr id="4" name="Image 0" descr="preencoded.png">    </p:cNvPr>
-          <p:cNvPicPr>
-            <a:picLocks noChangeAspect="1"/>
-          </p:cNvPicPr>
-          <p:nvPr/>
-        </p:nvPicPr>
-        <p:blipFill>
-          <a:blip r:embed="rId1"/>
-          <a:stretch>
-            <a:fillRect/>
-          </a:stretch>
-        </p:blipFill>
-        <p:spPr>
-          <a:xfrm>
-            <a:off x="914400" y="2084832"/>
-            <a:ext cx="274320" cy="274320"/>
-          </a:xfrm>
-          <a:prstGeom prst="rect">
-            <a:avLst/>
-          </a:prstGeom>
-        </p:spPr>
-      </p:pic>
-      <p:sp>
-        <p:nvSpPr>
-          <p:cNvPr id="5" name="Text 2"/>
-          <p:cNvSpPr/>
-          <p:nvPr/>
-        </p:nvSpPr>
-        <p:spPr>
-          <a:xfrm>
-            <a:off x="1280160" y="2029968"/>
-            <a:ext cx="2743200" cy="320040"/>
+      <p:sp>
+        <p:nvSpPr>
+          <p:cNvPr id="6" name="Text 3"/>
+          <p:cNvSpPr/>
+          <p:nvPr/>
+        </p:nvSpPr>
+        <p:spPr>
+          <a:xfrm>
+            <a:off x="7132320" y="2011680"/>
+            <a:ext cx="4114800" cy="365760"/>
           </a:xfrm>
           <a:prstGeom prst="rect">
             <a:avLst/>
@@ -5844,30 +6858,30 @@
               <a:buNone/>
             </a:pPr>
             <a:r>
-              <a:rPr lang="en-US" sz="1300" b="1" dirty="0">
-                <a:solidFill>
-                  <a:srgbClr val="16A34A"/>
+              <a:rPr lang="en-US" sz="1500" b="1" dirty="0">
+                <a:solidFill>
+                  <a:srgbClr val="0F766E"/>
                 </a:solidFill>
                 <a:latin typeface="Calibri" pitchFamily="34" charset="0"/>
                 <a:ea typeface="Calibri" pitchFamily="34" charset="-122"/>
                 <a:cs typeface="Calibri" pitchFamily="34" charset="-120"/>
               </a:rPr>
-              <a:t>GROUNDED</a:t>
-            </a:r>
-            <a:endParaRPr lang="en-US" sz="1300" dirty="0"/>
-          </a:p>
-        </p:txBody>
-      </p:sp>
-      <p:sp>
-        <p:nvSpPr>
-          <p:cNvPr id="6" name="Text 3"/>
-          <p:cNvSpPr/>
-          <p:nvPr/>
-        </p:nvSpPr>
-        <p:spPr>
-          <a:xfrm>
-            <a:off x="914400" y="2542032"/>
-            <a:ext cx="4754880" cy="822960"/>
+              <a:t>What this shows</a:t>
+            </a:r>
+            <a:endParaRPr lang="en-US" sz="1500" dirty="0"/>
+          </a:p>
+        </p:txBody>
+      </p:sp>
+      <p:sp>
+        <p:nvSpPr>
+          <p:cNvPr id="7" name="Text 4"/>
+          <p:cNvSpPr/>
+          <p:nvPr/>
+        </p:nvSpPr>
+        <p:spPr>
+          <a:xfrm>
+            <a:off x="7132320" y="2468880"/>
+            <a:ext cx="4114800" cy="2286000"/>
           </a:xfrm>
           <a:prstGeom prst="rect">
             <a:avLst/>
@@ -5879,11 +6893,18 @@
           <a:bodyPr wrap="square" lIns="0" tIns="0" rIns="0" bIns="0" rtlCol="0" anchor="t"/>
           <a:lstStyle/>
           <a:p>
-            <a:pPr indent="0" marL="0">
-              <a:buNone/>
-            </a:pPr>
-            <a:r>
-              <a:rPr lang="en-US" sz="1500" dirty="0">
+            <a:pPr marL="342900" indent="-342900">
+              <a:lnSpc>
+                <a:spcPct val="105000"/>
+              </a:lnSpc>
+              <a:spcAft>
+                <a:spcPts val="800"/>
+              </a:spcAft>
+              <a:buSzPct val="100000"/>
+              <a:buChar char="•"/>
+            </a:pPr>
+            <a:r>
+              <a:rPr lang="en-US" sz="1350" dirty="0">
                 <a:solidFill>
                   <a:srgbClr val="0F172A"/>
                 </a:solidFill>
@@ -5891,119 +6912,46 @@
                 <a:ea typeface="Calibri" pitchFamily="34" charset="-122"/>
                 <a:cs typeface="Calibri" pitchFamily="34" charset="-120"/>
               </a:rPr>
-              <a:t>Rule: E&amp;M to decide on major surgery is reportable with modifier 57.</a:t>
-            </a:r>
-            <a:endParaRPr lang="en-US" sz="1500" dirty="0"/>
-          </a:p>
-        </p:txBody>
-      </p:sp>
-      <p:sp>
-        <p:nvSpPr>
-          <p:cNvPr id="7" name="Text 4"/>
-          <p:cNvSpPr/>
-          <p:nvPr/>
-        </p:nvSpPr>
-        <p:spPr>
-          <a:xfrm>
-            <a:off x="914400" y="3456432"/>
-            <a:ext cx="4754880" cy="914400"/>
-          </a:xfrm>
-          <a:prstGeom prst="rect">
-            <a:avLst/>
-          </a:prstGeom>
-          <a:noFill/>
-          <a:ln/>
-        </p:spPr>
-        <p:txBody>
-          <a:bodyPr wrap="square" lIns="0" tIns="0" rIns="0" bIns="0" rtlCol="0" anchor="t"/>
-          <a:lstStyle/>
-          <a:p>
-            <a:pPr indent="0" marL="0">
-              <a:buNone/>
-            </a:pPr>
-            <a:r>
-              <a:rPr lang="en-US" sz="1300" i="1" dirty="0">
-                <a:solidFill>
-                  <a:srgbClr val="64748B"/>
+              <a:t>The version diff flags every section that changed between the 2024 and 2025 editions, the trigger to review a coding rule.</a:t>
+            </a:r>
+            <a:endParaRPr lang="en-US" sz="1350" dirty="0"/>
+          </a:p>
+          <a:p>
+            <a:pPr marL="342900" indent="-342900">
+              <a:lnSpc>
+                <a:spcPct val="105000"/>
+              </a:lnSpc>
+              <a:spcAft>
+                <a:spcPts val="800"/>
+              </a:spcAft>
+              <a:buSzPct val="100000"/>
+              <a:buChar char="•"/>
+            </a:pPr>
+            <a:r>
+              <a:rPr lang="en-US" sz="1350" dirty="0">
+                <a:solidFill>
+                  <a:srgbClr val="0F172A"/>
                 </a:solidFill>
                 <a:latin typeface="Calibri" pitchFamily="34" charset="0"/>
                 <a:ea typeface="Calibri" pitchFamily="34" charset="-122"/>
                 <a:cs typeface="Calibri" pitchFamily="34" charset="-120"/>
               </a:rPr>
-              <a:t>Quote “separately reportable with modifier 57” appears verbatim in the cited section.</a:t>
-            </a:r>
-            <a:endParaRPr lang="en-US" sz="1300" dirty="0"/>
-          </a:p>
-        </p:txBody>
-      </p:sp>
-      <p:sp>
-        <p:nvSpPr>
-          <p:cNvPr id="8" name="Shape 5"/>
-          <p:cNvSpPr/>
-          <p:nvPr/>
-        </p:nvSpPr>
-        <p:spPr>
-          <a:xfrm>
-            <a:off x="6217920" y="1828800"/>
-            <a:ext cx="5303520" cy="2743200"/>
-          </a:xfrm>
-          <a:prstGeom prst="roundRect">
-            <a:avLst>
-              <a:gd name="adj" fmla="val 2667"/>
-            </a:avLst>
-          </a:prstGeom>
-          <a:solidFill>
-            <a:srgbClr val="FFFFFF"/>
-          </a:solidFill>
-          <a:ln w="12700">
-            <a:solidFill>
-              <a:srgbClr val="E2E8F0"/>
-            </a:solidFill>
-            <a:prstDash val="solid"/>
-          </a:ln>
-          <a:effectLst>
-            <a:outerShdw sx="100000" sy="100000" kx="0" ky="0" algn="bl" rotWithShape="0" blurRad="101600" dist="38100" dir="5400000">
-              <a:srgbClr val="0F172A">
-                <a:alpha val="10000"/>
-              </a:srgbClr>
-            </a:outerShdw>
-          </a:effectLst>
-        </p:spPr>
-      </p:sp>
-      <p:pic>
-        <p:nvPicPr>
-          <p:cNvPr id="9" name="Image 1" descr="preencoded.png">    </p:cNvPr>
-          <p:cNvPicPr>
-            <a:picLocks noChangeAspect="1"/>
-          </p:cNvPicPr>
-          <p:nvPr/>
-        </p:nvPicPr>
-        <p:blipFill>
-          <a:blip r:embed="rId2"/>
-          <a:stretch>
-            <a:fillRect/>
-          </a:stretch>
-        </p:blipFill>
-        <p:spPr>
-          <a:xfrm>
-            <a:off x="6492240" y="2084832"/>
-            <a:ext cx="274320" cy="274320"/>
-          </a:xfrm>
-          <a:prstGeom prst="rect">
-            <a:avLst/>
-          </a:prstGeom>
-        </p:spPr>
-      </p:pic>
-      <p:sp>
-        <p:nvSpPr>
-          <p:cNvPr id="10" name="Text 6"/>
-          <p:cNvSpPr/>
-          <p:nvPr/>
-        </p:nvSpPr>
-        <p:spPr>
-          <a:xfrm>
-            <a:off x="6858000" y="2029968"/>
-            <a:ext cx="2743200" cy="320040"/>
+              <a:t>Pick any changed section and the agent explains the change in plain language.</a:t>
+            </a:r>
+            <a:endParaRPr lang="en-US" sz="1350" dirty="0"/>
+          </a:p>
+        </p:txBody>
+      </p:sp>
+      <p:sp>
+        <p:nvSpPr>
+          <p:cNvPr id="8" name="Text 5"/>
+          <p:cNvSpPr/>
+          <p:nvPr/>
+        </p:nvSpPr>
+        <p:spPr>
+          <a:xfrm>
+            <a:off x="6858000" y="5074920"/>
+            <a:ext cx="4663440" cy="1005840"/>
           </a:xfrm>
           <a:prstGeom prst="rect">
             <a:avLst/>
@@ -6012,141 +6960,27 @@
           <a:ln/>
         </p:spPr>
         <p:txBody>
-          <a:bodyPr wrap="square" lIns="0" tIns="0" rIns="0" bIns="0" rtlCol="0" anchor="ctr"/>
+          <a:bodyPr wrap="square" lIns="0" tIns="0" rIns="0" bIns="0" rtlCol="0" anchor="t"/>
           <a:lstStyle/>
           <a:p>
             <a:pPr indent="0" marL="0">
+              <a:lnSpc>
+                <a:spcPct val="105000"/>
+              </a:lnSpc>
               <a:buNone/>
             </a:pPr>
             <a:r>
-              <a:rPr lang="en-US" sz="1300" b="1" dirty="0">
-                <a:solidFill>
-                  <a:srgbClr val="DC2626"/>
+              <a:rPr lang="en-US" sz="1250" i="1" dirty="0">
+                <a:solidFill>
+                  <a:srgbClr val="64748B"/>
                 </a:solidFill>
                 <a:latin typeface="Calibri" pitchFamily="34" charset="0"/>
                 <a:ea typeface="Calibri" pitchFamily="34" charset="-122"/>
                 <a:cs typeface="Calibri" pitchFamily="34" charset="-120"/>
               </a:rPr>
-              <a:t>FLAGGED</a:t>
-            </a:r>
-            <a:endParaRPr lang="en-US" sz="1300" dirty="0"/>
-          </a:p>
-        </p:txBody>
-      </p:sp>
-      <p:sp>
-        <p:nvSpPr>
-          <p:cNvPr id="11" name="Text 7"/>
-          <p:cNvSpPr/>
-          <p:nvPr/>
-        </p:nvSpPr>
-        <p:spPr>
-          <a:xfrm>
-            <a:off x="6492240" y="2542032"/>
-            <a:ext cx="4754880" cy="822960"/>
-          </a:xfrm>
-          <a:prstGeom prst="rect">
-            <a:avLst/>
-          </a:prstGeom>
-          <a:noFill/>
-          <a:ln/>
-        </p:spPr>
-        <p:txBody>
-          <a:bodyPr wrap="square" lIns="0" tIns="0" rIns="0" bIns="0" rtlCol="0" anchor="t"/>
-          <a:lstStyle/>
-          <a:p>
-            <a:pPr indent="0" marL="0">
-              <a:buNone/>
-            </a:pPr>
-            <a:r>
-              <a:rPr lang="en-US" sz="1500" dirty="0">
-                <a:solidFill>
-                  <a:srgbClr val="0F172A"/>
-                </a:solidFill>
-                <a:latin typeface="Calibri" pitchFamily="34" charset="0"/>
-                <a:ea typeface="Calibri" pitchFamily="34" charset="-122"/>
-                <a:cs typeface="Calibri" pitchFamily="34" charset="-120"/>
-              </a:rPr>
-              <a:t>Rule whose quote was stitched together and is not verbatim in the source.</a:t>
-            </a:r>
-            <a:endParaRPr lang="en-US" sz="1500" dirty="0"/>
-          </a:p>
-        </p:txBody>
-      </p:sp>
-      <p:sp>
-        <p:nvSpPr>
-          <p:cNvPr id="12" name="Text 8"/>
-          <p:cNvSpPr/>
-          <p:nvPr/>
-        </p:nvSpPr>
-        <p:spPr>
-          <a:xfrm>
-            <a:off x="6492240" y="3456432"/>
-            <a:ext cx="4754880" cy="914400"/>
-          </a:xfrm>
-          <a:prstGeom prst="rect">
-            <a:avLst/>
-          </a:prstGeom>
-          <a:noFill/>
-          <a:ln/>
-        </p:spPr>
-        <p:txBody>
-          <a:bodyPr wrap="square" lIns="0" tIns="0" rIns="0" bIns="0" rtlCol="0" anchor="t"/>
-          <a:lstStyle/>
-          <a:p>
-            <a:pPr indent="0" marL="0">
-              <a:buNone/>
-            </a:pPr>
-            <a:r>
-              <a:rPr lang="en-US" sz="1300" i="1" dirty="0">
-                <a:solidFill>
-                  <a:srgbClr val="64748B"/>
-                </a:solidFill>
-                <a:latin typeface="Calibri" pitchFamily="34" charset="0"/>
-                <a:ea typeface="Calibri" pitchFamily="34" charset="-122"/>
-                <a:cs typeface="Calibri" pitchFamily="34" charset="-120"/>
-              </a:rPr>
-              <a:t>The check scores it below threshold and flags it for review, instead of trusting it.</a:t>
-            </a:r>
-            <a:endParaRPr lang="en-US" sz="1300" dirty="0"/>
-          </a:p>
-        </p:txBody>
-      </p:sp>
-      <p:sp>
-        <p:nvSpPr>
-          <p:cNvPr id="13" name="Text 9"/>
-          <p:cNvSpPr/>
-          <p:nvPr/>
-        </p:nvSpPr>
-        <p:spPr>
-          <a:xfrm>
-            <a:off x="640080" y="5029200"/>
-            <a:ext cx="10881360" cy="548640"/>
-          </a:xfrm>
-          <a:prstGeom prst="rect">
-            <a:avLst/>
-          </a:prstGeom>
-          <a:noFill/>
-          <a:ln/>
-        </p:spPr>
-        <p:txBody>
-          <a:bodyPr wrap="square" lIns="0" tIns="0" rIns="0" bIns="0" rtlCol="0" anchor="ctr"/>
-          <a:lstStyle/>
-          <a:p>
-            <a:pPr algn="ctr" indent="0" marL="0">
-              <a:buNone/>
-            </a:pPr>
-            <a:r>
-              <a:rPr lang="en-US" sz="1500" b="1" dirty="0">
-                <a:solidFill>
-                  <a:srgbClr val="0F766E"/>
-                </a:solidFill>
-                <a:latin typeface="Calibri" pitchFamily="34" charset="0"/>
-                <a:ea typeface="Calibri" pitchFamily="34" charset="-122"/>
-                <a:cs typeface="Calibri" pitchFamily="34" charset="-120"/>
-              </a:rPr>
-              <a:t>A hallucinated coding rule is a compliance failure. The system verifies every citation against the policy text.</a:t>
-            </a:r>
-            <a:endParaRPr lang="en-US" sz="1500" dirty="0"/>
+              <a:t>Example: Section Q went from “Gender-Specific Procedures” (2024) to “Reserved for future use” (2025). The system catches the retirement and explains it.</a:t>
+            </a:r>
+            <a:endParaRPr lang="en-US" sz="1250" dirty="0"/>
           </a:p>
         </p:txBody>
       </p:sp>
@@ -6158,9 +6992,9 @@
 </p:sld>
 </file>
 
-<file path=ppt/slides/slide7.xml><?xml version="1.0" encoding="utf-8"?>
+<file path=ppt/slides/slide8.xml><?xml version="1.0" encoding="utf-8"?>
 <p:sld xmlns:a="http://schemas.openxmlformats.org/drawingml/2006/main" xmlns:r="http://schemas.openxmlformats.org/officeDocument/2006/relationships" xmlns:p="http://schemas.openxmlformats.org/presentationml/2006/main">
-  <p:cSld name="Slide 7">
+  <p:cSld name="Slide 8">
     <p:bg>
       <p:bgPr>
         <a:solidFill>
@@ -6490,251 +7324,6 @@
               <a:t>Compare the 2024 and 2025 editions</a:t>
             </a:r>
             <a:endParaRPr lang="en-US" sz="1600" dirty="0"/>
-          </a:p>
-        </p:txBody>
-      </p:sp>
-    </p:spTree>
-  </p:cSld>
-  <p:clrMapOvr>
-    <a:masterClrMapping/>
-  </p:clrMapOvr>
-</p:sld>
-</file>
-
-<file path=ppt/slides/slide8.xml><?xml version="1.0" encoding="utf-8"?>
-<p:sld xmlns:a="http://schemas.openxmlformats.org/drawingml/2006/main" xmlns:r="http://schemas.openxmlformats.org/officeDocument/2006/relationships" xmlns:p="http://schemas.openxmlformats.org/presentationml/2006/main">
-  <p:cSld name="Slide 8">
-    <p:bg>
-      <p:bgPr>
-        <a:solidFill>
-          <a:srgbClr val="FFFFFF"/>
-        </a:solidFill>
-      </p:bgPr>
-    </p:bg>
-    <p:spTree>
-      <p:nvGrpSpPr>
-        <p:cNvPr id="1" name=""/>
-        <p:cNvGrpSpPr/>
-        <p:nvPr/>
-      </p:nvGrpSpPr>
-      <p:grpSpPr>
-        <a:xfrm>
-          <a:off x="0" y="0"/>
-          <a:ext cx="0" cy="0"/>
-          <a:chOff x="0" y="0"/>
-          <a:chExt cx="0" cy="0"/>
-        </a:xfrm>
-      </p:grpSpPr>
-      <p:sp>
-        <p:nvSpPr>
-          <p:cNvPr id="2" name="Text 0"/>
-          <p:cNvSpPr/>
-          <p:nvPr/>
-        </p:nvSpPr>
-        <p:spPr>
-          <a:xfrm>
-            <a:off x="640080" y="411480"/>
-            <a:ext cx="10881360" cy="640080"/>
-          </a:xfrm>
-          <a:prstGeom prst="rect">
-            <a:avLst/>
-          </a:prstGeom>
-          <a:noFill/>
-          <a:ln/>
-        </p:spPr>
-        <p:txBody>
-          <a:bodyPr wrap="square" lIns="0" tIns="0" rIns="0" bIns="0" rtlCol="0" anchor="ctr"/>
-          <a:lstStyle/>
-          <a:p>
-            <a:pPr indent="0" marL="0">
-              <a:buNone/>
-            </a:pPr>
-            <a:r>
-              <a:rPr lang="en-US" sz="3000" b="1" dirty="0">
-                <a:solidFill>
-                  <a:srgbClr val="0F172A"/>
-                </a:solidFill>
-                <a:latin typeface="Cambria" pitchFamily="34" charset="0"/>
-                <a:ea typeface="Cambria" pitchFamily="34" charset="-122"/>
-                <a:cs typeface="Cambria" pitchFamily="34" charset="-120"/>
-              </a:rPr>
-              <a:t>Results: honest, measured, reproducible</a:t>
-            </a:r>
-            <a:endParaRPr lang="en-US" sz="3000" dirty="0"/>
-          </a:p>
-        </p:txBody>
-      </p:sp>
-      <p:graphicFrame>
-        <p:nvGraphicFramePr>
-          <p:cNvPr id="3" name="Chart 0" descr=""/>
-          <p:cNvGraphicFramePr/>
-          <p:nvPr/>
-        </p:nvGraphicFramePr>
-        <p:xfrm>
-          <a:off x="731520" y="1920240"/>
-          <a:ext cx="6400800" cy="3840480"/>
-        </p:xfrm>
-        <a:graphic xmlns:a="http://schemas.openxmlformats.org/drawingml/2006/main">
-          <a:graphicData uri="http://schemas.openxmlformats.org/drawingml/2006/chart">
-            <c:chart xmlns:c="http://schemas.openxmlformats.org/drawingml/2006/chart" r:id="rId1"/>
-          </a:graphicData>
-        </a:graphic>
-      </p:graphicFrame>
-      <p:sp>
-        <p:nvSpPr>
-          <p:cNvPr id="4" name="Shape 1"/>
-          <p:cNvSpPr/>
-          <p:nvPr/>
-        </p:nvSpPr>
-        <p:spPr>
-          <a:xfrm>
-            <a:off x="7589520" y="1920240"/>
-            <a:ext cx="3931920" cy="3840480"/>
-          </a:xfrm>
-          <a:prstGeom prst="roundRect">
-            <a:avLst>
-              <a:gd name="adj" fmla="val 1905"/>
-            </a:avLst>
-          </a:prstGeom>
-          <a:solidFill>
-            <a:srgbClr val="E8F2F0"/>
-          </a:solidFill>
-          <a:ln w="12700">
-            <a:solidFill>
-              <a:srgbClr val="E2E8F0"/>
-            </a:solidFill>
-            <a:prstDash val="solid"/>
-          </a:ln>
-          <a:effectLst>
-            <a:outerShdw sx="100000" sy="100000" kx="0" ky="0" algn="bl" rotWithShape="0" blurRad="101600" dist="38100" dir="5400000">
-              <a:srgbClr val="0F172A">
-                <a:alpha val="10000"/>
-              </a:srgbClr>
-            </a:outerShdw>
-          </a:effectLst>
-        </p:spPr>
-      </p:sp>
-      <p:sp>
-        <p:nvSpPr>
-          <p:cNvPr id="5" name="Text 2"/>
-          <p:cNvSpPr/>
-          <p:nvPr/>
-        </p:nvSpPr>
-        <p:spPr>
-          <a:xfrm>
-            <a:off x="7863840" y="2148840"/>
-            <a:ext cx="3383280" cy="365760"/>
-          </a:xfrm>
-          <a:prstGeom prst="rect">
-            <a:avLst/>
-          </a:prstGeom>
-          <a:noFill/>
-          <a:ln/>
-        </p:spPr>
-        <p:txBody>
-          <a:bodyPr wrap="square" lIns="0" tIns="0" rIns="0" bIns="0" rtlCol="0" anchor="ctr"/>
-          <a:lstStyle/>
-          <a:p>
-            <a:pPr indent="0" marL="0">
-              <a:buNone/>
-            </a:pPr>
-            <a:r>
-              <a:rPr lang="en-US" sz="1500" b="1" dirty="0">
-                <a:solidFill>
-                  <a:srgbClr val="0F766E"/>
-                </a:solidFill>
-                <a:latin typeface="Calibri" pitchFamily="34" charset="0"/>
-                <a:ea typeface="Calibri" pitchFamily="34" charset="-122"/>
-                <a:cs typeface="Calibri" pitchFamily="34" charset="-120"/>
-              </a:rPr>
-              <a:t>How to read this</a:t>
-            </a:r>
-            <a:endParaRPr lang="en-US" sz="1500" dirty="0"/>
-          </a:p>
-        </p:txBody>
-      </p:sp>
-      <p:sp>
-        <p:nvSpPr>
-          <p:cNvPr id="6" name="Text 3"/>
-          <p:cNvSpPr/>
-          <p:nvPr/>
-        </p:nvSpPr>
-        <p:spPr>
-          <a:xfrm>
-            <a:off x="7863840" y="2606040"/>
-            <a:ext cx="3383280" cy="3017520"/>
-          </a:xfrm>
-          <a:prstGeom prst="rect">
-            <a:avLst/>
-          </a:prstGeom>
-          <a:noFill/>
-          <a:ln/>
-        </p:spPr>
-        <p:txBody>
-          <a:bodyPr wrap="square" lIns="0" tIns="0" rIns="0" bIns="0" rtlCol="0" anchor="t"/>
-          <a:lstStyle/>
-          <a:p>
-            <a:pPr marL="342900" indent="-342900">
-              <a:spcAft>
-                <a:spcPts val="800"/>
-              </a:spcAft>
-              <a:buSzPct val="100000"/>
-              <a:buChar char="•"/>
-            </a:pPr>
-            <a:r>
-              <a:rPr lang="en-US" sz="1400" dirty="0">
-                <a:solidFill>
-                  <a:srgbClr val="0F172A"/>
-                </a:solidFill>
-                <a:latin typeface="Calibri" pitchFamily="34" charset="0"/>
-                <a:ea typeface="Calibri" pitchFamily="34" charset="-122"/>
-                <a:cs typeface="Calibri" pitchFamily="34" charset="-120"/>
-              </a:rPr>
-              <a:t>The agent reached 100% faithfulness and recall on some runs.</a:t>
-            </a:r>
-            <a:endParaRPr lang="en-US" sz="1400" dirty="0"/>
-          </a:p>
-          <a:p>
-            <a:pPr marL="342900" indent="-342900">
-              <a:spcAft>
-                <a:spcPts val="800"/>
-              </a:spcAft>
-              <a:buSzPct val="100000"/>
-              <a:buChar char="•"/>
-            </a:pPr>
-            <a:r>
-              <a:rPr lang="en-US" sz="1400" dirty="0">
-                <a:solidFill>
-                  <a:srgbClr val="0F172A"/>
-                </a:solidFill>
-                <a:latin typeface="Calibri" pitchFamily="34" charset="0"/>
-                <a:ea typeface="Calibri" pitchFamily="34" charset="-122"/>
-                <a:cs typeface="Calibri" pitchFamily="34" charset="-120"/>
-              </a:rPr>
-              <a:t>The model is non-deterministic, so we report the range, not a single best run.</a:t>
-            </a:r>
-            <a:endParaRPr lang="en-US" sz="1400" dirty="0"/>
-          </a:p>
-          <a:p>
-            <a:pPr marL="342900" indent="-342900">
-              <a:spcAft>
-                <a:spcPts val="800"/>
-              </a:spcAft>
-              <a:buSzPct val="100000"/>
-              <a:buChar char="•"/>
-            </a:pPr>
-            <a:r>
-              <a:rPr lang="en-US" sz="1400" dirty="0">
-                <a:solidFill>
-                  <a:srgbClr val="0F172A"/>
-                </a:solidFill>
-                <a:latin typeface="Calibri" pitchFamily="34" charset="0"/>
-                <a:ea typeface="Calibri" pitchFamily="34" charset="-122"/>
-                <a:cs typeface="Calibri" pitchFamily="34" charset="-120"/>
-              </a:rPr>
-              <a:t>Evaluated on a hand-labeled set of 7 provisions, small by design.</a:t>
-            </a:r>
-            <a:endParaRPr lang="en-US" sz="1400" dirty="0"/>
           </a:p>
         </p:txBody>
       </p:sp>
@@ -6803,100 +7392,38 @@
                 <a:ea typeface="Cambria" pitchFamily="34" charset="-122"/>
                 <a:cs typeface="Cambria" pitchFamily="34" charset="-120"/>
               </a:rPr>
-              <a:t>Limitations and what is next</a:t>
+              <a:t>Results: honest, measured, reproducible</a:t>
             </a:r>
             <a:endParaRPr lang="en-US" sz="3000" dirty="0"/>
           </a:p>
         </p:txBody>
       </p:sp>
-      <p:sp>
-        <p:nvSpPr>
-          <p:cNvPr id="3" name="Shape 1"/>
-          <p:cNvSpPr/>
-          <p:nvPr/>
-        </p:nvSpPr>
-        <p:spPr>
-          <a:xfrm>
-            <a:off x="640080" y="1874520"/>
-            <a:ext cx="5349240" cy="1554480"/>
-          </a:xfrm>
-          <a:prstGeom prst="roundRect">
-            <a:avLst>
-              <a:gd name="adj" fmla="val 4706"/>
-            </a:avLst>
-          </a:prstGeom>
-          <a:solidFill>
-            <a:srgbClr val="FFFFFF"/>
-          </a:solidFill>
-          <a:ln w="12700">
-            <a:solidFill>
-              <a:srgbClr val="E2E8F0"/>
-            </a:solidFill>
-            <a:prstDash val="solid"/>
-          </a:ln>
-          <a:effectLst>
-            <a:outerShdw sx="100000" sy="100000" kx="0" ky="0" algn="bl" rotWithShape="0" blurRad="101600" dist="38100" dir="5400000">
-              <a:srgbClr val="0F172A">
-                <a:alpha val="10000"/>
-              </a:srgbClr>
-            </a:outerShdw>
-          </a:effectLst>
-        </p:spPr>
-      </p:sp>
-      <p:sp>
-        <p:nvSpPr>
-          <p:cNvPr id="4" name="Shape 2"/>
-          <p:cNvSpPr/>
-          <p:nvPr/>
-        </p:nvSpPr>
-        <p:spPr>
-          <a:xfrm>
-            <a:off x="960120" y="2148840"/>
-            <a:ext cx="502920" cy="502920"/>
-          </a:xfrm>
-          <a:prstGeom prst="ellipse">
-            <a:avLst/>
-          </a:prstGeom>
-          <a:solidFill>
-            <a:srgbClr val="0F766E"/>
-          </a:solidFill>
-          <a:ln/>
-        </p:spPr>
-      </p:sp>
-      <p:pic>
-        <p:nvPicPr>
-          <p:cNvPr id="5" name="Image 0" descr="preencoded.png">    </p:cNvPr>
-          <p:cNvPicPr>
-            <a:picLocks noChangeAspect="1"/>
-          </p:cNvPicPr>
-          <p:nvPr/>
-        </p:nvPicPr>
-        <p:blipFill>
-          <a:blip r:embed="rId1"/>
-          <a:stretch>
-            <a:fillRect/>
-          </a:stretch>
-        </p:blipFill>
-        <p:spPr>
-          <a:xfrm>
-            <a:off x="1085850" y="2274570"/>
-            <a:ext cx="251460" cy="251460"/>
-          </a:xfrm>
-          <a:prstGeom prst="rect">
-            <a:avLst/>
-          </a:prstGeom>
-        </p:spPr>
-      </p:pic>
-      <p:sp>
-        <p:nvSpPr>
-          <p:cNvPr id="6" name="Text 3"/>
-          <p:cNvSpPr/>
-          <p:nvPr/>
-        </p:nvSpPr>
-        <p:spPr>
-          <a:xfrm>
-            <a:off x="1600200" y="2130552"/>
-            <a:ext cx="4160520" cy="457200"/>
+      <p:graphicFrame>
+        <p:nvGraphicFramePr>
+          <p:cNvPr id="3" name="Chart 0" descr=""/>
+          <p:cNvGraphicFramePr/>
+          <p:nvPr/>
+        </p:nvGraphicFramePr>
+        <p:xfrm>
+          <a:off x="502920" y="1783080"/>
+          <a:ext cx="5303520" cy="3383280"/>
+        </p:xfrm>
+        <a:graphic xmlns:a="http://schemas.openxmlformats.org/drawingml/2006/main">
+          <a:graphicData uri="http://schemas.openxmlformats.org/drawingml/2006/chart">
+            <c:chart xmlns:c="http://schemas.openxmlformats.org/drawingml/2006/chart" r:id="rId1"/>
+          </a:graphicData>
+        </a:graphic>
+      </p:graphicFrame>
+      <p:sp>
+        <p:nvSpPr>
+          <p:cNvPr id="4" name="Text 1"/>
+          <p:cNvSpPr/>
+          <p:nvPr/>
+        </p:nvSpPr>
+        <p:spPr>
+          <a:xfrm>
+            <a:off x="6172200" y="1783080"/>
+            <a:ext cx="5623560" cy="320040"/>
           </a:xfrm>
           <a:prstGeom prst="rect">
             <a:avLst/>
@@ -6912,7 +7439,7 @@
               <a:buNone/>
             </a:pPr>
             <a:r>
-              <a:rPr lang="en-US" sz="1700" b="1" dirty="0">
+              <a:rPr lang="en-US" sz="1300" b="1" dirty="0">
                 <a:solidFill>
                   <a:srgbClr val="0F766E"/>
                 </a:solidFill>
@@ -6920,108 +7447,15 @@
                 <a:ea typeface="Calibri" pitchFamily="34" charset="-122"/>
                 <a:cs typeface="Calibri" pitchFamily="34" charset="-120"/>
               </a:rPr>
-              <a:t>Keyword retrieval</a:t>
-            </a:r>
-            <a:endParaRPr lang="en-US" sz="1700" dirty="0"/>
-          </a:p>
-        </p:txBody>
-      </p:sp>
-      <p:sp>
-        <p:nvSpPr>
-          <p:cNvPr id="7" name="Text 4"/>
-          <p:cNvSpPr/>
-          <p:nvPr/>
-        </p:nvSpPr>
-        <p:spPr>
-          <a:xfrm>
-            <a:off x="960120" y="2660904"/>
-            <a:ext cx="4709160" cy="640080"/>
-          </a:xfrm>
-          <a:prstGeom prst="rect">
-            <a:avLst/>
-          </a:prstGeom>
-          <a:noFill/>
-          <a:ln/>
-        </p:spPr>
-        <p:txBody>
-          <a:bodyPr wrap="square" lIns="0" tIns="0" rIns="0" bIns="0" rtlCol="0" anchor="t"/>
-          <a:lstStyle/>
-          <a:p>
-            <a:pPr indent="0" marL="0">
-              <a:buNone/>
-            </a:pPr>
-            <a:r>
-              <a:rPr lang="en-US" sz="1400" dirty="0">
-                <a:solidFill>
-                  <a:srgbClr val="64748B"/>
-                </a:solidFill>
-                <a:latin typeface="Calibri" pitchFamily="34" charset="0"/>
-                <a:ea typeface="Calibri" pitchFamily="34" charset="-122"/>
-                <a:cs typeface="Calibri" pitchFamily="34" charset="-120"/>
-              </a:rPr>
-              <a:t>Uses keyword matching today; semantic embeddings are the next upgrade.</a:t>
-            </a:r>
-            <a:endParaRPr lang="en-US" sz="1400" dirty="0"/>
-          </a:p>
-        </p:txBody>
-      </p:sp>
-      <p:sp>
-        <p:nvSpPr>
-          <p:cNvPr id="8" name="Shape 5"/>
-          <p:cNvSpPr/>
-          <p:nvPr/>
-        </p:nvSpPr>
-        <p:spPr>
-          <a:xfrm>
-            <a:off x="6355080" y="1874520"/>
-            <a:ext cx="5349240" cy="1554480"/>
-          </a:xfrm>
-          <a:prstGeom prst="roundRect">
-            <a:avLst>
-              <a:gd name="adj" fmla="val 4706"/>
-            </a:avLst>
-          </a:prstGeom>
-          <a:solidFill>
-            <a:srgbClr val="FFFFFF"/>
-          </a:solidFill>
-          <a:ln w="12700">
-            <a:solidFill>
-              <a:srgbClr val="E2E8F0"/>
-            </a:solidFill>
-            <a:prstDash val="solid"/>
-          </a:ln>
-          <a:effectLst>
-            <a:outerShdw sx="100000" sy="100000" kx="0" ky="0" algn="bl" rotWithShape="0" blurRad="101600" dist="38100" dir="5400000">
-              <a:srgbClr val="0F172A">
-                <a:alpha val="10000"/>
-              </a:srgbClr>
-            </a:outerShdw>
-          </a:effectLst>
-        </p:spPr>
-      </p:sp>
-      <p:sp>
-        <p:nvSpPr>
-          <p:cNvPr id="9" name="Shape 6"/>
-          <p:cNvSpPr/>
-          <p:nvPr/>
-        </p:nvSpPr>
-        <p:spPr>
-          <a:xfrm>
-            <a:off x="6675120" y="2148840"/>
-            <a:ext cx="502920" cy="502920"/>
-          </a:xfrm>
-          <a:prstGeom prst="ellipse">
-            <a:avLst/>
-          </a:prstGeom>
-          <a:solidFill>
-            <a:srgbClr val="0F766E"/>
-          </a:solidFill>
-          <a:ln/>
-        </p:spPr>
+              <a:t>From the evaluation harness (live)</a:t>
+            </a:r>
+            <a:endParaRPr lang="en-US" sz="1300" dirty="0"/>
+          </a:p>
+        </p:txBody>
       </p:sp>
       <p:pic>
         <p:nvPicPr>
-          <p:cNvPr id="10" name="Image 1" descr="preencoded.png">    </p:cNvPr>
+          <p:cNvPr id="5" name="Image 0" descr="/mnt/user-data/outputs/cotiviti-policy-to-rules/assets/screenshot_evaluation.png">    </p:cNvPr>
           <p:cNvPicPr>
             <a:picLocks noChangeAspect="1"/>
           </p:cNvPicPr>
@@ -7035,8 +7469,8 @@
         </p:blipFill>
         <p:spPr>
           <a:xfrm>
-            <a:off x="6800850" y="2274570"/>
-            <a:ext cx="251460" cy="251460"/>
+            <a:off x="6172200" y="2194560"/>
+            <a:ext cx="5623560" cy="2359152"/>
           </a:xfrm>
           <a:prstGeom prst="rect">
             <a:avLst/>
@@ -7045,14 +7479,41 @@
       </p:pic>
       <p:sp>
         <p:nvSpPr>
-          <p:cNvPr id="11" name="Text 7"/>
-          <p:cNvSpPr/>
-          <p:nvPr/>
-        </p:nvSpPr>
-        <p:spPr>
-          <a:xfrm>
-            <a:off x="7315200" y="2130552"/>
-            <a:ext cx="4160520" cy="457200"/>
+          <p:cNvPr id="6" name="Shape 2"/>
+          <p:cNvSpPr/>
+          <p:nvPr/>
+        </p:nvSpPr>
+        <p:spPr>
+          <a:xfrm>
+            <a:off x="6172200" y="2194560"/>
+            <a:ext cx="5623560" cy="2359152"/>
+          </a:xfrm>
+          <a:prstGeom prst="rect">
+            <a:avLst/>
+          </a:prstGeom>
+          <a:solidFill>
+            <a:srgbClr val="FFFFFF">
+              <a:alpha val="0"/>
+            </a:srgbClr>
+          </a:solidFill>
+          <a:ln w="12700">
+            <a:solidFill>
+              <a:srgbClr val="D9DEE5"/>
+            </a:solidFill>
+            <a:prstDash val="solid"/>
+          </a:ln>
+        </p:spPr>
+      </p:sp>
+      <p:sp>
+        <p:nvSpPr>
+          <p:cNvPr id="7" name="Text 3"/>
+          <p:cNvSpPr/>
+          <p:nvPr/>
+        </p:nvSpPr>
+        <p:spPr>
+          <a:xfrm>
+            <a:off x="502920" y="5349240"/>
+            <a:ext cx="11292840" cy="1005840"/>
           </a:xfrm>
           <a:prstGeom prst="rect">
             <a:avLst/>
@@ -7065,371 +7526,23 @@
           <a:lstStyle/>
           <a:p>
             <a:pPr indent="0" marL="0">
+              <a:lnSpc>
+                <a:spcPct val="112000"/>
+              </a:lnSpc>
               <a:buNone/>
             </a:pPr>
             <a:r>
-              <a:rPr lang="en-US" sz="1700" b="1" dirty="0">
-                <a:solidFill>
-                  <a:srgbClr val="0F766E"/>
+              <a:rPr lang="en-US" sz="1300" dirty="0">
+                <a:solidFill>
+                  <a:srgbClr val="0F172A"/>
                 </a:solidFill>
                 <a:latin typeface="Calibri" pitchFamily="34" charset="0"/>
                 <a:ea typeface="Calibri" pitchFamily="34" charset="-122"/>
                 <a:cs typeface="Calibri" pitchFamily="34" charset="-120"/>
               </a:rPr>
-              <a:t>Small evaluation set</a:t>
-            </a:r>
-            <a:endParaRPr lang="en-US" sz="1700" dirty="0"/>
-          </a:p>
-        </p:txBody>
-      </p:sp>
-      <p:sp>
-        <p:nvSpPr>
-          <p:cNvPr id="12" name="Text 8"/>
-          <p:cNvSpPr/>
-          <p:nvPr/>
-        </p:nvSpPr>
-        <p:spPr>
-          <a:xfrm>
-            <a:off x="6675120" y="2660904"/>
-            <a:ext cx="4709160" cy="640080"/>
-          </a:xfrm>
-          <a:prstGeom prst="rect">
-            <a:avLst/>
-          </a:prstGeom>
-          <a:noFill/>
-          <a:ln/>
-        </p:spPr>
-        <p:txBody>
-          <a:bodyPr wrap="square" lIns="0" tIns="0" rIns="0" bIns="0" rtlCol="0" anchor="t"/>
-          <a:lstStyle/>
-          <a:p>
-            <a:pPr indent="0" marL="0">
-              <a:buNone/>
-            </a:pPr>
-            <a:r>
-              <a:rPr lang="en-US" sz="1400" dirty="0">
-                <a:solidFill>
-                  <a:srgbClr val="64748B"/>
-                </a:solidFill>
-                <a:latin typeface="Calibri" pitchFamily="34" charset="0"/>
-                <a:ea typeface="Calibri" pitchFamily="34" charset="-122"/>
-                <a:cs typeface="Calibri" pitchFamily="34" charset="-120"/>
-              </a:rPr>
-              <a:t>Seven labeled provisions: a feasibility signal, not a production accuracy claim.</a:t>
-            </a:r>
-            <a:endParaRPr lang="en-US" sz="1400" dirty="0"/>
-          </a:p>
-        </p:txBody>
-      </p:sp>
-      <p:sp>
-        <p:nvSpPr>
-          <p:cNvPr id="13" name="Shape 9"/>
-          <p:cNvSpPr/>
-          <p:nvPr/>
-        </p:nvSpPr>
-        <p:spPr>
-          <a:xfrm>
-            <a:off x="640080" y="3657600"/>
-            <a:ext cx="5349240" cy="1554480"/>
-          </a:xfrm>
-          <a:prstGeom prst="roundRect">
-            <a:avLst>
-              <a:gd name="adj" fmla="val 4706"/>
-            </a:avLst>
-          </a:prstGeom>
-          <a:solidFill>
-            <a:srgbClr val="FFFFFF"/>
-          </a:solidFill>
-          <a:ln w="12700">
-            <a:solidFill>
-              <a:srgbClr val="E2E8F0"/>
-            </a:solidFill>
-            <a:prstDash val="solid"/>
-          </a:ln>
-          <a:effectLst>
-            <a:outerShdw sx="100000" sy="100000" kx="0" ky="0" algn="bl" rotWithShape="0" blurRad="101600" dist="38100" dir="5400000">
-              <a:srgbClr val="0F172A">
-                <a:alpha val="10000"/>
-              </a:srgbClr>
-            </a:outerShdw>
-          </a:effectLst>
-        </p:spPr>
-      </p:sp>
-      <p:sp>
-        <p:nvSpPr>
-          <p:cNvPr id="14" name="Shape 10"/>
-          <p:cNvSpPr/>
-          <p:nvPr/>
-        </p:nvSpPr>
-        <p:spPr>
-          <a:xfrm>
-            <a:off x="960120" y="3931920"/>
-            <a:ext cx="502920" cy="502920"/>
-          </a:xfrm>
-          <a:prstGeom prst="ellipse">
-            <a:avLst/>
-          </a:prstGeom>
-          <a:solidFill>
-            <a:srgbClr val="0F766E"/>
-          </a:solidFill>
-          <a:ln/>
-        </p:spPr>
-      </p:sp>
-      <p:pic>
-        <p:nvPicPr>
-          <p:cNvPr id="15" name="Image 2" descr="preencoded.png">    </p:cNvPr>
-          <p:cNvPicPr>
-            <a:picLocks noChangeAspect="1"/>
-          </p:cNvPicPr>
-          <p:nvPr/>
-        </p:nvPicPr>
-        <p:blipFill>
-          <a:blip r:embed="rId3"/>
-          <a:stretch>
-            <a:fillRect/>
-          </a:stretch>
-        </p:blipFill>
-        <p:spPr>
-          <a:xfrm>
-            <a:off x="1085850" y="4057650"/>
-            <a:ext cx="251460" cy="251460"/>
-          </a:xfrm>
-          <a:prstGeom prst="rect">
-            <a:avLst/>
-          </a:prstGeom>
-        </p:spPr>
-      </p:pic>
-      <p:sp>
-        <p:nvSpPr>
-          <p:cNvPr id="16" name="Text 11"/>
-          <p:cNvSpPr/>
-          <p:nvPr/>
-        </p:nvSpPr>
-        <p:spPr>
-          <a:xfrm>
-            <a:off x="1600200" y="3913632"/>
-            <a:ext cx="4160520" cy="457200"/>
-          </a:xfrm>
-          <a:prstGeom prst="rect">
-            <a:avLst/>
-          </a:prstGeom>
-          <a:noFill/>
-          <a:ln/>
-        </p:spPr>
-        <p:txBody>
-          <a:bodyPr wrap="square" lIns="0" tIns="0" rIns="0" bIns="0" rtlCol="0" anchor="ctr"/>
-          <a:lstStyle/>
-          <a:p>
-            <a:pPr indent="0" marL="0">
-              <a:buNone/>
-            </a:pPr>
-            <a:r>
-              <a:rPr lang="en-US" sz="1700" b="1" dirty="0">
-                <a:solidFill>
-                  <a:srgbClr val="0F766E"/>
-                </a:solidFill>
-                <a:latin typeface="Calibri" pitchFamily="34" charset="0"/>
-                <a:ea typeface="Calibri" pitchFamily="34" charset="-122"/>
-                <a:cs typeface="Calibri" pitchFamily="34" charset="-120"/>
-              </a:rPr>
-              <a:t>Model-agnostic by design</a:t>
-            </a:r>
-            <a:endParaRPr lang="en-US" sz="1700" dirty="0"/>
-          </a:p>
-        </p:txBody>
-      </p:sp>
-      <p:sp>
-        <p:nvSpPr>
-          <p:cNvPr id="17" name="Text 12"/>
-          <p:cNvSpPr/>
-          <p:nvPr/>
-        </p:nvSpPr>
-        <p:spPr>
-          <a:xfrm>
-            <a:off x="960120" y="4443984"/>
-            <a:ext cx="4709160" cy="640080"/>
-          </a:xfrm>
-          <a:prstGeom prst="rect">
-            <a:avLst/>
-          </a:prstGeom>
-          <a:noFill/>
-          <a:ln/>
-        </p:spPr>
-        <p:txBody>
-          <a:bodyPr wrap="square" lIns="0" tIns="0" rIns="0" bIns="0" rtlCol="0" anchor="t"/>
-          <a:lstStyle/>
-          <a:p>
-            <a:pPr indent="0" marL="0">
-              <a:buNone/>
-            </a:pPr>
-            <a:r>
-              <a:rPr lang="en-US" sz="1400" dirty="0">
-                <a:solidFill>
-                  <a:srgbClr val="64748B"/>
-                </a:solidFill>
-                <a:latin typeface="Calibri" pitchFamily="34" charset="0"/>
-                <a:ea typeface="Calibri" pitchFamily="34" charset="-122"/>
-                <a:cs typeface="Calibri" pitchFamily="34" charset="-120"/>
-              </a:rPr>
-              <a:t>Ran on a free open model; the same pipeline runs on any production model.</a:t>
-            </a:r>
-            <a:endParaRPr lang="en-US" sz="1400" dirty="0"/>
-          </a:p>
-        </p:txBody>
-      </p:sp>
-      <p:sp>
-        <p:nvSpPr>
-          <p:cNvPr id="18" name="Shape 13"/>
-          <p:cNvSpPr/>
-          <p:nvPr/>
-        </p:nvSpPr>
-        <p:spPr>
-          <a:xfrm>
-            <a:off x="6355080" y="3657600"/>
-            <a:ext cx="5349240" cy="1554480"/>
-          </a:xfrm>
-          <a:prstGeom prst="roundRect">
-            <a:avLst>
-              <a:gd name="adj" fmla="val 4706"/>
-            </a:avLst>
-          </a:prstGeom>
-          <a:solidFill>
-            <a:srgbClr val="FFFFFF"/>
-          </a:solidFill>
-          <a:ln w="12700">
-            <a:solidFill>
-              <a:srgbClr val="E2E8F0"/>
-            </a:solidFill>
-            <a:prstDash val="solid"/>
-          </a:ln>
-          <a:effectLst>
-            <a:outerShdw sx="100000" sy="100000" kx="0" ky="0" algn="bl" rotWithShape="0" blurRad="101600" dist="38100" dir="5400000">
-              <a:srgbClr val="0F172A">
-                <a:alpha val="10000"/>
-              </a:srgbClr>
-            </a:outerShdw>
-          </a:effectLst>
-        </p:spPr>
-      </p:sp>
-      <p:sp>
-        <p:nvSpPr>
-          <p:cNvPr id="19" name="Shape 14"/>
-          <p:cNvSpPr/>
-          <p:nvPr/>
-        </p:nvSpPr>
-        <p:spPr>
-          <a:xfrm>
-            <a:off x="6675120" y="3931920"/>
-            <a:ext cx="502920" cy="502920"/>
-          </a:xfrm>
-          <a:prstGeom prst="ellipse">
-            <a:avLst/>
-          </a:prstGeom>
-          <a:solidFill>
-            <a:srgbClr val="0F766E"/>
-          </a:solidFill>
-          <a:ln/>
-        </p:spPr>
-      </p:sp>
-      <p:pic>
-        <p:nvPicPr>
-          <p:cNvPr id="20" name="Image 3" descr="preencoded.png">    </p:cNvPr>
-          <p:cNvPicPr>
-            <a:picLocks noChangeAspect="1"/>
-          </p:cNvPicPr>
-          <p:nvPr/>
-        </p:nvPicPr>
-        <p:blipFill>
-          <a:blip r:embed="rId4"/>
-          <a:stretch>
-            <a:fillRect/>
-          </a:stretch>
-        </p:blipFill>
-        <p:spPr>
-          <a:xfrm>
-            <a:off x="6800850" y="4057650"/>
-            <a:ext cx="251460" cy="251460"/>
-          </a:xfrm>
-          <a:prstGeom prst="rect">
-            <a:avLst/>
-          </a:prstGeom>
-        </p:spPr>
-      </p:pic>
-      <p:sp>
-        <p:nvSpPr>
-          <p:cNvPr id="21" name="Text 15"/>
-          <p:cNvSpPr/>
-          <p:nvPr/>
-        </p:nvSpPr>
-        <p:spPr>
-          <a:xfrm>
-            <a:off x="7315200" y="3913632"/>
-            <a:ext cx="4160520" cy="457200"/>
-          </a:xfrm>
-          <a:prstGeom prst="rect">
-            <a:avLst/>
-          </a:prstGeom>
-          <a:noFill/>
-          <a:ln/>
-        </p:spPr>
-        <p:txBody>
-          <a:bodyPr wrap="square" lIns="0" tIns="0" rIns="0" bIns="0" rtlCol="0" anchor="ctr"/>
-          <a:lstStyle/>
-          <a:p>
-            <a:pPr indent="0" marL="0">
-              <a:buNone/>
-            </a:pPr>
-            <a:r>
-              <a:rPr lang="en-US" sz="1700" b="1" dirty="0">
-                <a:solidFill>
-                  <a:srgbClr val="0F766E"/>
-                </a:solidFill>
-                <a:latin typeface="Calibri" pitchFamily="34" charset="0"/>
-                <a:ea typeface="Calibri" pitchFamily="34" charset="-122"/>
-                <a:cs typeface="Calibri" pitchFamily="34" charset="-120"/>
-              </a:rPr>
-              <a:t>Scope: one chapter</a:t>
-            </a:r>
-            <a:endParaRPr lang="en-US" sz="1700" dirty="0"/>
-          </a:p>
-        </p:txBody>
-      </p:sp>
-      <p:sp>
-        <p:nvSpPr>
-          <p:cNvPr id="22" name="Text 16"/>
-          <p:cNvSpPr/>
-          <p:nvPr/>
-        </p:nvSpPr>
-        <p:spPr>
-          <a:xfrm>
-            <a:off x="6675120" y="4443984"/>
-            <a:ext cx="4709160" cy="640080"/>
-          </a:xfrm>
-          <a:prstGeom prst="rect">
-            <a:avLst/>
-          </a:prstGeom>
-          <a:noFill/>
-          <a:ln/>
-        </p:spPr>
-        <p:txBody>
-          <a:bodyPr wrap="square" lIns="0" tIns="0" rIns="0" bIns="0" rtlCol="0" anchor="t"/>
-          <a:lstStyle/>
-          <a:p>
-            <a:pPr indent="0" marL="0">
-              <a:buNone/>
-            </a:pPr>
-            <a:r>
-              <a:rPr lang="en-US" sz="1400" dirty="0">
-                <a:solidFill>
-                  <a:srgbClr val="64748B"/>
-                </a:solidFill>
-                <a:latin typeface="Calibri" pitchFamily="34" charset="0"/>
-                <a:ea typeface="Calibri" pitchFamily="34" charset="-122"/>
-                <a:cs typeface="Calibri" pitchFamily="34" charset="-120"/>
-              </a:rPr>
-              <a:t>Demonstrated on Chapter 1 of the NCCI manual; the same approach generalizes to the full manual and other policy sources.</a:t>
-            </a:r>
-            <a:endParaRPr lang="en-US" sz="1400" dirty="0"/>
+              <a:t>The agent reached 100% on some runs; a representative run scored 88% faithfulness and 86% recall. We report the range, not a single best run, and the harness shows exactly what was missed and what was flagged. The evaluation set is small by design (7 labeled provisions).</a:t>
+            </a:r>
+            <a:endParaRPr lang="en-US" sz="1300" dirty="0"/>
           </a:p>
         </p:txBody>
       </p:sp>

</xml_diff>